<commit_message>
Week 2 Milestone: Dockerized FastAPI, PostgreSQL models, PyMuPDF/pdfplumber ingestion & Researcher Portal Auth
</commit_message>
<xml_diff>
--- a/GrantLens_Week1_Final_Presentation.pptx
+++ b/GrantLens_Week1_Final_Presentation.pptx
@@ -5,32 +5,32 @@
     <p:sldMasterId id="2147483648" r:id="rId1"/>
   </p:sldMasterIdLst>
   <p:sldIdLst>
-    <p:sldId id="256" r:id="rId2"/>
-    <p:sldId id="257" r:id="rId3"/>
-    <p:sldId id="258" r:id="rId4"/>
-    <p:sldId id="259" r:id="rId5"/>
-    <p:sldId id="260" r:id="rId6"/>
-    <p:sldId id="261" r:id="rId7"/>
-    <p:sldId id="262" r:id="rId8"/>
-    <p:sldId id="263" r:id="rId9"/>
-    <p:sldId id="264" r:id="rId10"/>
-    <p:sldId id="265" r:id="rId11"/>
-    <p:sldId id="266" r:id="rId12"/>
-    <p:sldId id="267" r:id="rId13"/>
-    <p:sldId id="268" r:id="rId14"/>
-    <p:sldId id="269" r:id="rId15"/>
-    <p:sldId id="270" r:id="rId16"/>
-    <p:sldId id="271" r:id="rId17"/>
-    <p:sldId id="272" r:id="rId18"/>
-    <p:sldId id="273" r:id="rId19"/>
-    <p:sldId id="274" r:id="rId20"/>
-    <p:sldId id="275" r:id="rId21"/>
-    <p:sldId id="276" r:id="rId22"/>
-    <p:sldId id="277" r:id="rId23"/>
-    <p:sldId id="278" r:id="rId24"/>
-    <p:sldId id="279" r:id="rId25"/>
+    <p:sldId id="256" r:id="rId7"/>
+    <p:sldId id="257" r:id="rId8"/>
+    <p:sldId id="258" r:id="rId9"/>
+    <p:sldId id="259" r:id="rId10"/>
+    <p:sldId id="260" r:id="rId11"/>
+    <p:sldId id="261" r:id="rId12"/>
+    <p:sldId id="262" r:id="rId13"/>
+    <p:sldId id="263" r:id="rId14"/>
+    <p:sldId id="264" r:id="rId15"/>
+    <p:sldId id="265" r:id="rId16"/>
+    <p:sldId id="266" r:id="rId17"/>
+    <p:sldId id="267" r:id="rId18"/>
+    <p:sldId id="268" r:id="rId19"/>
+    <p:sldId id="269" r:id="rId20"/>
+    <p:sldId id="270" r:id="rId21"/>
+    <p:sldId id="271" r:id="rId22"/>
+    <p:sldId id="272" r:id="rId23"/>
+    <p:sldId id="273" r:id="rId24"/>
+    <p:sldId id="274" r:id="rId25"/>
+    <p:sldId id="275" r:id="rId26"/>
+    <p:sldId id="276" r:id="rId27"/>
+    <p:sldId id="277" r:id="rId28"/>
+    <p:sldId id="278" r:id="rId29"/>
+    <p:sldId id="279" r:id="rId30"/>
   </p:sldIdLst>
-  <p:sldSz cx="12188825" cy="6858000"/>
+  <p:sldSz cx="12188952" cy="6858000" type="screen4x3"/>
   <p:notesSz cx="6858000" cy="9144000"/>
   <p:defaultTextStyle>
     <a:defPPr>
@@ -127,22 +127,6 @@
       </a:defRPr>
     </a:lvl9pPr>
   </p:defaultTextStyle>
-  <p:extLst>
-    <p:ext uri="{EFAFB233-063F-42B5-8137-9DF3F51BA10A}">
-      <p15:sldGuideLst xmlns:p15="http://schemas.microsoft.com/office/powerpoint/2012/main">
-        <p15:guide id="1" orient="horz" pos="2160">
-          <p15:clr>
-            <a:srgbClr val="A4A3A4"/>
-          </p15:clr>
-        </p15:guide>
-        <p15:guide id="2" pos="2880">
-          <p15:clr>
-            <a:srgbClr val="A4A3A4"/>
-          </p15:clr>
-        </p15:guide>
-      </p15:sldGuideLst>
-    </p:ext>
-  </p:extLst>
 </p:presentation>
 </file>
 
@@ -184,9 +168,10 @@
           <a:lstStyle/>
           <a:p>
             <a:r>
-              <a:rPr lang="en-US"/>
+              <a:rPr lang="en-US" smtClean="0"/>
               <a:t>Click to edit Master title style</a:t>
             </a:r>
+            <a:endParaRPr lang="en-US"/>
           </a:p>
         </p:txBody>
       </p:sp>
@@ -302,9 +287,10 @@
           </a:lstStyle>
           <a:p>
             <a:r>
-              <a:rPr lang="en-US"/>
+              <a:rPr lang="en-US" smtClean="0"/>
               <a:t>Click to edit Master subtitle style</a:t>
             </a:r>
+            <a:endParaRPr lang="en-US"/>
           </a:p>
         </p:txBody>
       </p:sp>
@@ -325,7 +311,7 @@
           <a:p>
             <a:fld id="{5BCAD085-E8A6-8845-BD4E-CB4CCA059FC4}" type="datetimeFigureOut">
               <a:rPr lang="en-US" smtClean="0"/>
-              <a:t>12-Oct-26</a:t>
+              <a:t>1/27/13</a:t>
             </a:fld>
             <a:endParaRPr lang="en-US"/>
           </a:p>
@@ -419,9 +405,10 @@
           <a:lstStyle/>
           <a:p>
             <a:r>
-              <a:rPr lang="en-US"/>
+              <a:rPr lang="en-US" smtClean="0"/>
               <a:t>Click to edit Master title style</a:t>
             </a:r>
+            <a:endParaRPr lang="en-US"/>
           </a:p>
         </p:txBody>
       </p:sp>
@@ -442,37 +429,38 @@
           <a:p>
             <a:pPr lvl="0"/>
             <a:r>
-              <a:rPr lang="en-US"/>
+              <a:rPr lang="en-US" smtClean="0"/>
               <a:t>Click to edit Master text styles</a:t>
             </a:r>
           </a:p>
           <a:p>
             <a:pPr lvl="1"/>
             <a:r>
-              <a:rPr lang="en-US"/>
+              <a:rPr lang="en-US" smtClean="0"/>
               <a:t>Second level</a:t>
             </a:r>
           </a:p>
           <a:p>
             <a:pPr lvl="2"/>
             <a:r>
-              <a:rPr lang="en-US"/>
+              <a:rPr lang="en-US" smtClean="0"/>
               <a:t>Third level</a:t>
             </a:r>
           </a:p>
           <a:p>
             <a:pPr lvl="3"/>
             <a:r>
-              <a:rPr lang="en-US"/>
+              <a:rPr lang="en-US" smtClean="0"/>
               <a:t>Fourth level</a:t>
             </a:r>
           </a:p>
           <a:p>
             <a:pPr lvl="4"/>
             <a:r>
-              <a:rPr lang="en-US"/>
+              <a:rPr lang="en-US" smtClean="0"/>
               <a:t>Fifth level</a:t>
             </a:r>
+            <a:endParaRPr lang="en-US"/>
           </a:p>
         </p:txBody>
       </p:sp>
@@ -493,7 +481,7 @@
           <a:p>
             <a:fld id="{5BCAD085-E8A6-8845-BD4E-CB4CCA059FC4}" type="datetimeFigureOut">
               <a:rPr lang="en-US" smtClean="0"/>
-              <a:t>12-Oct-26</a:t>
+              <a:t>1/27/13</a:t>
             </a:fld>
             <a:endParaRPr lang="en-US"/>
           </a:p>
@@ -592,9 +580,10 @@
           <a:lstStyle/>
           <a:p>
             <a:r>
-              <a:rPr lang="en-US"/>
+              <a:rPr lang="en-US" smtClean="0"/>
               <a:t>Click to edit Master title style</a:t>
             </a:r>
+            <a:endParaRPr lang="en-US"/>
           </a:p>
         </p:txBody>
       </p:sp>
@@ -620,37 +609,38 @@
           <a:p>
             <a:pPr lvl="0"/>
             <a:r>
-              <a:rPr lang="en-US"/>
+              <a:rPr lang="en-US" smtClean="0"/>
               <a:t>Click to edit Master text styles</a:t>
             </a:r>
           </a:p>
           <a:p>
             <a:pPr lvl="1"/>
             <a:r>
-              <a:rPr lang="en-US"/>
+              <a:rPr lang="en-US" smtClean="0"/>
               <a:t>Second level</a:t>
             </a:r>
           </a:p>
           <a:p>
             <a:pPr lvl="2"/>
             <a:r>
-              <a:rPr lang="en-US"/>
+              <a:rPr lang="en-US" smtClean="0"/>
               <a:t>Third level</a:t>
             </a:r>
           </a:p>
           <a:p>
             <a:pPr lvl="3"/>
             <a:r>
-              <a:rPr lang="en-US"/>
+              <a:rPr lang="en-US" smtClean="0"/>
               <a:t>Fourth level</a:t>
             </a:r>
           </a:p>
           <a:p>
             <a:pPr lvl="4"/>
             <a:r>
-              <a:rPr lang="en-US"/>
+              <a:rPr lang="en-US" smtClean="0"/>
               <a:t>Fifth level</a:t>
             </a:r>
+            <a:endParaRPr lang="en-US"/>
           </a:p>
         </p:txBody>
       </p:sp>
@@ -671,7 +661,7 @@
           <a:p>
             <a:fld id="{5BCAD085-E8A6-8845-BD4E-CB4CCA059FC4}" type="datetimeFigureOut">
               <a:rPr lang="en-US" smtClean="0"/>
-              <a:t>12-Oct-26</a:t>
+              <a:t>1/27/13</a:t>
             </a:fld>
             <a:endParaRPr lang="en-US"/>
           </a:p>
@@ -765,9 +755,10 @@
           <a:lstStyle/>
           <a:p>
             <a:r>
-              <a:rPr lang="en-US"/>
+              <a:rPr lang="en-US" smtClean="0"/>
               <a:t>Click to edit Master title style</a:t>
             </a:r>
+            <a:endParaRPr lang="en-US"/>
           </a:p>
         </p:txBody>
       </p:sp>
@@ -788,37 +779,38 @@
           <a:p>
             <a:pPr lvl="0"/>
             <a:r>
-              <a:rPr lang="en-US"/>
+              <a:rPr lang="en-US" smtClean="0"/>
               <a:t>Click to edit Master text styles</a:t>
             </a:r>
           </a:p>
           <a:p>
             <a:pPr lvl="1"/>
             <a:r>
-              <a:rPr lang="en-US"/>
+              <a:rPr lang="en-US" smtClean="0"/>
               <a:t>Second level</a:t>
             </a:r>
           </a:p>
           <a:p>
             <a:pPr lvl="2"/>
             <a:r>
-              <a:rPr lang="en-US"/>
+              <a:rPr lang="en-US" smtClean="0"/>
               <a:t>Third level</a:t>
             </a:r>
           </a:p>
           <a:p>
             <a:pPr lvl="3"/>
             <a:r>
-              <a:rPr lang="en-US"/>
+              <a:rPr lang="en-US" smtClean="0"/>
               <a:t>Fourth level</a:t>
             </a:r>
           </a:p>
           <a:p>
             <a:pPr lvl="4"/>
             <a:r>
-              <a:rPr lang="en-US"/>
+              <a:rPr lang="en-US" smtClean="0"/>
               <a:t>Fifth level</a:t>
             </a:r>
+            <a:endParaRPr lang="en-US"/>
           </a:p>
         </p:txBody>
       </p:sp>
@@ -839,7 +831,7 @@
           <a:p>
             <a:fld id="{5BCAD085-E8A6-8845-BD4E-CB4CCA059FC4}" type="datetimeFigureOut">
               <a:rPr lang="en-US" smtClean="0"/>
-              <a:t>12-Oct-26</a:t>
+              <a:t>1/27/13</a:t>
             </a:fld>
             <a:endParaRPr lang="en-US"/>
           </a:p>
@@ -942,9 +934,10 @@
           </a:lstStyle>
           <a:p>
             <a:r>
-              <a:rPr lang="en-US"/>
+              <a:rPr lang="en-US" smtClean="0"/>
               <a:t>Click to edit Master title style</a:t>
             </a:r>
+            <a:endParaRPr lang="en-US"/>
           </a:p>
         </p:txBody>
       </p:sp>
@@ -1061,7 +1054,7 @@
           <a:p>
             <a:pPr lvl="0"/>
             <a:r>
-              <a:rPr lang="en-US"/>
+              <a:rPr lang="en-US" smtClean="0"/>
               <a:t>Click to edit Master text styles</a:t>
             </a:r>
           </a:p>
@@ -1084,7 +1077,7 @@
           <a:p>
             <a:fld id="{5BCAD085-E8A6-8845-BD4E-CB4CCA059FC4}" type="datetimeFigureOut">
               <a:rPr lang="en-US" smtClean="0"/>
-              <a:t>12-Oct-26</a:t>
+              <a:t>1/27/13</a:t>
             </a:fld>
             <a:endParaRPr lang="en-US"/>
           </a:p>
@@ -1178,9 +1171,10 @@
           <a:lstStyle/>
           <a:p>
             <a:r>
-              <a:rPr lang="en-US"/>
+              <a:rPr lang="en-US" smtClean="0"/>
               <a:t>Click to edit Master title style</a:t>
             </a:r>
+            <a:endParaRPr lang="en-US"/>
           </a:p>
         </p:txBody>
       </p:sp>
@@ -1234,37 +1228,38 @@
           <a:p>
             <a:pPr lvl="0"/>
             <a:r>
-              <a:rPr lang="en-US"/>
+              <a:rPr lang="en-US" smtClean="0"/>
               <a:t>Click to edit Master text styles</a:t>
             </a:r>
           </a:p>
           <a:p>
             <a:pPr lvl="1"/>
             <a:r>
-              <a:rPr lang="en-US"/>
+              <a:rPr lang="en-US" smtClean="0"/>
               <a:t>Second level</a:t>
             </a:r>
           </a:p>
           <a:p>
             <a:pPr lvl="2"/>
             <a:r>
-              <a:rPr lang="en-US"/>
+              <a:rPr lang="en-US" smtClean="0"/>
               <a:t>Third level</a:t>
             </a:r>
           </a:p>
           <a:p>
             <a:pPr lvl="3"/>
             <a:r>
-              <a:rPr lang="en-US"/>
+              <a:rPr lang="en-US" smtClean="0"/>
               <a:t>Fourth level</a:t>
             </a:r>
           </a:p>
           <a:p>
             <a:pPr lvl="4"/>
             <a:r>
-              <a:rPr lang="en-US"/>
+              <a:rPr lang="en-US" smtClean="0"/>
               <a:t>Fifth level</a:t>
             </a:r>
+            <a:endParaRPr lang="en-US"/>
           </a:p>
         </p:txBody>
       </p:sp>
@@ -1318,37 +1313,38 @@
           <a:p>
             <a:pPr lvl="0"/>
             <a:r>
-              <a:rPr lang="en-US"/>
+              <a:rPr lang="en-US" smtClean="0"/>
               <a:t>Click to edit Master text styles</a:t>
             </a:r>
           </a:p>
           <a:p>
             <a:pPr lvl="1"/>
             <a:r>
-              <a:rPr lang="en-US"/>
+              <a:rPr lang="en-US" smtClean="0"/>
               <a:t>Second level</a:t>
             </a:r>
           </a:p>
           <a:p>
             <a:pPr lvl="2"/>
             <a:r>
-              <a:rPr lang="en-US"/>
+              <a:rPr lang="en-US" smtClean="0"/>
               <a:t>Third level</a:t>
             </a:r>
           </a:p>
           <a:p>
             <a:pPr lvl="3"/>
             <a:r>
-              <a:rPr lang="en-US"/>
+              <a:rPr lang="en-US" smtClean="0"/>
               <a:t>Fourth level</a:t>
             </a:r>
           </a:p>
           <a:p>
             <a:pPr lvl="4"/>
             <a:r>
-              <a:rPr lang="en-US"/>
+              <a:rPr lang="en-US" smtClean="0"/>
               <a:t>Fifth level</a:t>
             </a:r>
+            <a:endParaRPr lang="en-US"/>
           </a:p>
         </p:txBody>
       </p:sp>
@@ -1369,7 +1365,7 @@
           <a:p>
             <a:fld id="{5BCAD085-E8A6-8845-BD4E-CB4CCA059FC4}" type="datetimeFigureOut">
               <a:rPr lang="en-US" smtClean="0"/>
-              <a:t>12-Oct-26</a:t>
+              <a:t>1/27/13</a:t>
             </a:fld>
             <a:endParaRPr lang="en-US"/>
           </a:p>
@@ -1467,9 +1463,10 @@
           </a:lstStyle>
           <a:p>
             <a:r>
-              <a:rPr lang="en-US"/>
+              <a:rPr lang="en-US" smtClean="0"/>
               <a:t>Click to edit Master title style</a:t>
             </a:r>
+            <a:endParaRPr lang="en-US"/>
           </a:p>
         </p:txBody>
       </p:sp>
@@ -1532,7 +1529,7 @@
           <a:p>
             <a:pPr lvl="0"/>
             <a:r>
-              <a:rPr lang="en-US"/>
+              <a:rPr lang="en-US" smtClean="0"/>
               <a:t>Click to edit Master text styles</a:t>
             </a:r>
           </a:p>
@@ -1588,37 +1585,38 @@
           <a:p>
             <a:pPr lvl="0"/>
             <a:r>
-              <a:rPr lang="en-US"/>
+              <a:rPr lang="en-US" smtClean="0"/>
               <a:t>Click to edit Master text styles</a:t>
             </a:r>
           </a:p>
           <a:p>
             <a:pPr lvl="1"/>
             <a:r>
-              <a:rPr lang="en-US"/>
+              <a:rPr lang="en-US" smtClean="0"/>
               <a:t>Second level</a:t>
             </a:r>
           </a:p>
           <a:p>
             <a:pPr lvl="2"/>
             <a:r>
-              <a:rPr lang="en-US"/>
+              <a:rPr lang="en-US" smtClean="0"/>
               <a:t>Third level</a:t>
             </a:r>
           </a:p>
           <a:p>
             <a:pPr lvl="3"/>
             <a:r>
-              <a:rPr lang="en-US"/>
+              <a:rPr lang="en-US" smtClean="0"/>
               <a:t>Fourth level</a:t>
             </a:r>
           </a:p>
           <a:p>
             <a:pPr lvl="4"/>
             <a:r>
-              <a:rPr lang="en-US"/>
+              <a:rPr lang="en-US" smtClean="0"/>
               <a:t>Fifth level</a:t>
             </a:r>
+            <a:endParaRPr lang="en-US"/>
           </a:p>
         </p:txBody>
       </p:sp>
@@ -1681,7 +1679,7 @@
           <a:p>
             <a:pPr lvl="0"/>
             <a:r>
-              <a:rPr lang="en-US"/>
+              <a:rPr lang="en-US" smtClean="0"/>
               <a:t>Click to edit Master text styles</a:t>
             </a:r>
           </a:p>
@@ -1737,37 +1735,38 @@
           <a:p>
             <a:pPr lvl="0"/>
             <a:r>
-              <a:rPr lang="en-US"/>
+              <a:rPr lang="en-US" smtClean="0"/>
               <a:t>Click to edit Master text styles</a:t>
             </a:r>
           </a:p>
           <a:p>
             <a:pPr lvl="1"/>
             <a:r>
-              <a:rPr lang="en-US"/>
+              <a:rPr lang="en-US" smtClean="0"/>
               <a:t>Second level</a:t>
             </a:r>
           </a:p>
           <a:p>
             <a:pPr lvl="2"/>
             <a:r>
-              <a:rPr lang="en-US"/>
+              <a:rPr lang="en-US" smtClean="0"/>
               <a:t>Third level</a:t>
             </a:r>
           </a:p>
           <a:p>
             <a:pPr lvl="3"/>
             <a:r>
-              <a:rPr lang="en-US"/>
+              <a:rPr lang="en-US" smtClean="0"/>
               <a:t>Fourth level</a:t>
             </a:r>
           </a:p>
           <a:p>
             <a:pPr lvl="4"/>
             <a:r>
-              <a:rPr lang="en-US"/>
+              <a:rPr lang="en-US" smtClean="0"/>
               <a:t>Fifth level</a:t>
             </a:r>
+            <a:endParaRPr lang="en-US"/>
           </a:p>
         </p:txBody>
       </p:sp>
@@ -1788,7 +1787,7 @@
           <a:p>
             <a:fld id="{5BCAD085-E8A6-8845-BD4E-CB4CCA059FC4}" type="datetimeFigureOut">
               <a:rPr lang="en-US" smtClean="0"/>
-              <a:t>12-Oct-26</a:t>
+              <a:t>1/27/13</a:t>
             </a:fld>
             <a:endParaRPr lang="en-US"/>
           </a:p>
@@ -1882,9 +1881,10 @@
           <a:lstStyle/>
           <a:p>
             <a:r>
-              <a:rPr lang="en-US"/>
+              <a:rPr lang="en-US" smtClean="0"/>
               <a:t>Click to edit Master title style</a:t>
             </a:r>
+            <a:endParaRPr lang="en-US"/>
           </a:p>
         </p:txBody>
       </p:sp>
@@ -1905,7 +1905,7 @@
           <a:p>
             <a:fld id="{5BCAD085-E8A6-8845-BD4E-CB4CCA059FC4}" type="datetimeFigureOut">
               <a:rPr lang="en-US" smtClean="0"/>
-              <a:t>12-Oct-26</a:t>
+              <a:t>1/27/13</a:t>
             </a:fld>
             <a:endParaRPr lang="en-US"/>
           </a:p>
@@ -2000,7 +2000,7 @@
           <a:p>
             <a:fld id="{5BCAD085-E8A6-8845-BD4E-CB4CCA059FC4}" type="datetimeFigureOut">
               <a:rPr lang="en-US" smtClean="0"/>
-              <a:t>12-Oct-26</a:t>
+              <a:t>1/27/13</a:t>
             </a:fld>
             <a:endParaRPr lang="en-US"/>
           </a:p>
@@ -2103,9 +2103,10 @@
           </a:lstStyle>
           <a:p>
             <a:r>
-              <a:rPr lang="en-US"/>
+              <a:rPr lang="en-US" smtClean="0"/>
               <a:t>Click to edit Master title style</a:t>
             </a:r>
+            <a:endParaRPr lang="en-US"/>
           </a:p>
         </p:txBody>
       </p:sp>
@@ -2159,37 +2160,38 @@
           <a:p>
             <a:pPr lvl="0"/>
             <a:r>
-              <a:rPr lang="en-US"/>
+              <a:rPr lang="en-US" smtClean="0"/>
               <a:t>Click to edit Master text styles</a:t>
             </a:r>
           </a:p>
           <a:p>
             <a:pPr lvl="1"/>
             <a:r>
-              <a:rPr lang="en-US"/>
+              <a:rPr lang="en-US" smtClean="0"/>
               <a:t>Second level</a:t>
             </a:r>
           </a:p>
           <a:p>
             <a:pPr lvl="2"/>
             <a:r>
-              <a:rPr lang="en-US"/>
+              <a:rPr lang="en-US" smtClean="0"/>
               <a:t>Third level</a:t>
             </a:r>
           </a:p>
           <a:p>
             <a:pPr lvl="3"/>
             <a:r>
-              <a:rPr lang="en-US"/>
+              <a:rPr lang="en-US" smtClean="0"/>
               <a:t>Fourth level</a:t>
             </a:r>
           </a:p>
           <a:p>
             <a:pPr lvl="4"/>
             <a:r>
-              <a:rPr lang="en-US"/>
+              <a:rPr lang="en-US" smtClean="0"/>
               <a:t>Fifth level</a:t>
             </a:r>
+            <a:endParaRPr lang="en-US"/>
           </a:p>
         </p:txBody>
       </p:sp>
@@ -2252,7 +2254,7 @@
           <a:p>
             <a:pPr lvl="0"/>
             <a:r>
-              <a:rPr lang="en-US"/>
+              <a:rPr lang="en-US" smtClean="0"/>
               <a:t>Click to edit Master text styles</a:t>
             </a:r>
           </a:p>
@@ -2275,7 +2277,7 @@
           <a:p>
             <a:fld id="{5BCAD085-E8A6-8845-BD4E-CB4CCA059FC4}" type="datetimeFigureOut">
               <a:rPr lang="en-US" smtClean="0"/>
-              <a:t>12-Oct-26</a:t>
+              <a:t>1/27/13</a:t>
             </a:fld>
             <a:endParaRPr lang="en-US"/>
           </a:p>
@@ -2378,9 +2380,10 @@
           </a:lstStyle>
           <a:p>
             <a:r>
-              <a:rPr lang="en-US"/>
+              <a:rPr lang="en-US" smtClean="0"/>
               <a:t>Click to edit Master title style</a:t>
             </a:r>
+            <a:endParaRPr lang="en-US"/>
           </a:p>
         </p:txBody>
       </p:sp>
@@ -2504,7 +2507,7 @@
           <a:p>
             <a:pPr lvl="0"/>
             <a:r>
-              <a:rPr lang="en-US"/>
+              <a:rPr lang="en-US" smtClean="0"/>
               <a:t>Click to edit Master text styles</a:t>
             </a:r>
           </a:p>
@@ -2527,7 +2530,7 @@
           <a:p>
             <a:fld id="{5BCAD085-E8A6-8845-BD4E-CB4CCA059FC4}" type="datetimeFigureOut">
               <a:rPr lang="en-US" smtClean="0"/>
-              <a:t>12-Oct-26</a:t>
+              <a:t>1/27/13</a:t>
             </a:fld>
             <a:endParaRPr lang="en-US"/>
           </a:p>
@@ -2636,9 +2639,10 @@
           <a:lstStyle/>
           <a:p>
             <a:r>
-              <a:rPr lang="en-US"/>
+              <a:rPr lang="en-US" smtClean="0"/>
               <a:t>Click to edit Master title style</a:t>
             </a:r>
+            <a:endParaRPr lang="en-US"/>
           </a:p>
         </p:txBody>
       </p:sp>
@@ -2669,37 +2673,38 @@
           <a:p>
             <a:pPr lvl="0"/>
             <a:r>
-              <a:rPr lang="en-US"/>
+              <a:rPr lang="en-US" smtClean="0"/>
               <a:t>Click to edit Master text styles</a:t>
             </a:r>
           </a:p>
           <a:p>
             <a:pPr lvl="1"/>
             <a:r>
-              <a:rPr lang="en-US"/>
+              <a:rPr lang="en-US" smtClean="0"/>
               <a:t>Second level</a:t>
             </a:r>
           </a:p>
           <a:p>
             <a:pPr lvl="2"/>
             <a:r>
-              <a:rPr lang="en-US"/>
+              <a:rPr lang="en-US" smtClean="0"/>
               <a:t>Third level</a:t>
             </a:r>
           </a:p>
           <a:p>
             <a:pPr lvl="3"/>
             <a:r>
-              <a:rPr lang="en-US"/>
+              <a:rPr lang="en-US" smtClean="0"/>
               <a:t>Fourth level</a:t>
             </a:r>
           </a:p>
           <a:p>
             <a:pPr lvl="4"/>
             <a:r>
-              <a:rPr lang="en-US"/>
+              <a:rPr lang="en-US" smtClean="0"/>
               <a:t>Fifth level</a:t>
             </a:r>
+            <a:endParaRPr lang="en-US"/>
           </a:p>
         </p:txBody>
       </p:sp>
@@ -2738,7 +2743,7 @@
           <a:p>
             <a:fld id="{5BCAD085-E8A6-8845-BD4E-CB4CCA059FC4}" type="datetimeFigureOut">
               <a:rPr lang="en-US" smtClean="0"/>
-              <a:t>12-Oct-26</a:t>
+              <a:t>1/27/13</a:t>
             </a:fld>
             <a:endParaRPr lang="en-US"/>
           </a:p>
@@ -3097,7 +3102,7 @@
 </file>
 
 <file path=ppt/slides/slide1.xml><?xml version="1.0" encoding="utf-8"?>
-<p:sld xmlns:a="http://schemas.openxmlformats.org/drawingml/2006/main" xmlns:r="http://schemas.openxmlformats.org/officeDocument/2006/relationships" xmlns:p="http://schemas.openxmlformats.org/presentationml/2006/main">
+<p:sld xmlns:a="http://schemas.openxmlformats.org/drawingml/2006/main" xmlns:p="http://schemas.openxmlformats.org/presentationml/2006/main" xmlns:r="http://schemas.openxmlformats.org/officeDocument/2006/relationships">
   <p:cSld>
     <p:spTree>
       <p:nvGrpSpPr>
@@ -3105,14 +3110,7 @@
         <p:cNvGrpSpPr/>
         <p:nvPr/>
       </p:nvGrpSpPr>
-      <p:grpSpPr>
-        <a:xfrm>
-          <a:off x="0" y="0"/>
-          <a:ext cx="0" cy="0"/>
-          <a:chOff x="0" y="0"/>
-          <a:chExt cx="0" cy="0"/>
-        </a:xfrm>
-      </p:grpSpPr>
+      <p:grpSpPr/>
       <p:sp>
         <p:nvSpPr>
           <p:cNvPr id="2" name="Rectangle 1"/>
@@ -3153,7 +3151,6 @@
           <a:lstStyle/>
           <a:p>
             <a:pPr algn="ctr"/>
-            <a:endParaRPr/>
           </a:p>
         </p:txBody>
       </p:sp>
@@ -3232,7 +3229,6 @@
           <a:lstStyle/>
           <a:p>
             <a:pPr algn="ctr"/>
-            <a:endParaRPr/>
           </a:p>
         </p:txBody>
       </p:sp>
@@ -3412,7 +3408,7 @@
           </a:fontRef>
         </p:style>
         <p:txBody>
-          <a:bodyPr wrap="none" rtlCol="0" anchor="ctr"/>
+          <a:bodyPr rtlCol="0" anchor="ctr" wrap="none"/>
           <a:lstStyle/>
           <a:p>
             <a:pPr algn="ctr"/>
@@ -3437,7 +3433,7 @@
 </file>
 
 <file path=ppt/slides/slide10.xml><?xml version="1.0" encoding="utf-8"?>
-<p:sld xmlns:a="http://schemas.openxmlformats.org/drawingml/2006/main" xmlns:r="http://schemas.openxmlformats.org/officeDocument/2006/relationships" xmlns:p="http://schemas.openxmlformats.org/presentationml/2006/main">
+<p:sld xmlns:a="http://schemas.openxmlformats.org/drawingml/2006/main" xmlns:p="http://schemas.openxmlformats.org/presentationml/2006/main" xmlns:r="http://schemas.openxmlformats.org/officeDocument/2006/relationships">
   <p:cSld>
     <p:spTree>
       <p:nvGrpSpPr>
@@ -3445,14 +3441,7 @@
         <p:cNvGrpSpPr/>
         <p:nvPr/>
       </p:nvGrpSpPr>
-      <p:grpSpPr>
-        <a:xfrm>
-          <a:off x="0" y="0"/>
-          <a:ext cx="0" cy="0"/>
-          <a:chOff x="0" y="0"/>
-          <a:chExt cx="0" cy="0"/>
-        </a:xfrm>
-      </p:grpSpPr>
+      <p:grpSpPr/>
       <p:sp>
         <p:nvSpPr>
           <p:cNvPr id="2" name="Rectangle 1"/>
@@ -3493,7 +3482,6 @@
           <a:lstStyle/>
           <a:p>
             <a:pPr algn="ctr"/>
-            <a:endParaRPr/>
           </a:p>
         </p:txBody>
       </p:sp>
@@ -3537,7 +3525,6 @@
           <a:lstStyle/>
           <a:p>
             <a:pPr algn="ctr"/>
-            <a:endParaRPr/>
           </a:p>
         </p:txBody>
       </p:sp>
@@ -3688,7 +3675,6 @@
           <a:lstStyle/>
           <a:p>
             <a:pPr algn="ctr"/>
-            <a:endParaRPr/>
           </a:p>
         </p:txBody>
       </p:sp>
@@ -3790,7 +3776,6 @@
           <a:lstStyle/>
           <a:p>
             <a:pPr algn="ctr"/>
-            <a:endParaRPr/>
           </a:p>
         </p:txBody>
       </p:sp>
@@ -3906,7 +3891,6 @@
           <a:lstStyle/>
           <a:p>
             <a:pPr algn="ctr"/>
-            <a:endParaRPr/>
           </a:p>
         </p:txBody>
       </p:sp>
@@ -4022,7 +4006,6 @@
           <a:lstStyle/>
           <a:p>
             <a:pPr algn="ctr"/>
-            <a:endParaRPr/>
           </a:p>
         </p:txBody>
       </p:sp>
@@ -4138,7 +4121,6 @@
           <a:lstStyle/>
           <a:p>
             <a:pPr algn="ctr"/>
-            <a:endParaRPr/>
           </a:p>
         </p:txBody>
       </p:sp>
@@ -4254,7 +4236,6 @@
           <a:lstStyle/>
           <a:p>
             <a:pPr algn="ctr"/>
-            <a:endParaRPr/>
           </a:p>
         </p:txBody>
       </p:sp>
@@ -4337,7 +4318,7 @@
 </file>
 
 <file path=ppt/slides/slide11.xml><?xml version="1.0" encoding="utf-8"?>
-<p:sld xmlns:a="http://schemas.openxmlformats.org/drawingml/2006/main" xmlns:r="http://schemas.openxmlformats.org/officeDocument/2006/relationships" xmlns:p="http://schemas.openxmlformats.org/presentationml/2006/main">
+<p:sld xmlns:a="http://schemas.openxmlformats.org/drawingml/2006/main" xmlns:p="http://schemas.openxmlformats.org/presentationml/2006/main" xmlns:r="http://schemas.openxmlformats.org/officeDocument/2006/relationships">
   <p:cSld>
     <p:spTree>
       <p:nvGrpSpPr>
@@ -4345,14 +4326,7 @@
         <p:cNvGrpSpPr/>
         <p:nvPr/>
       </p:nvGrpSpPr>
-      <p:grpSpPr>
-        <a:xfrm>
-          <a:off x="0" y="0"/>
-          <a:ext cx="0" cy="0"/>
-          <a:chOff x="0" y="0"/>
-          <a:chExt cx="0" cy="0"/>
-        </a:xfrm>
-      </p:grpSpPr>
+      <p:grpSpPr/>
       <p:sp>
         <p:nvSpPr>
           <p:cNvPr id="2" name="Rectangle 1"/>
@@ -4393,7 +4367,6 @@
           <a:lstStyle/>
           <a:p>
             <a:pPr algn="ctr"/>
-            <a:endParaRPr/>
           </a:p>
         </p:txBody>
       </p:sp>
@@ -4437,7 +4410,6 @@
           <a:lstStyle/>
           <a:p>
             <a:pPr algn="ctr"/>
-            <a:endParaRPr/>
           </a:p>
         </p:txBody>
       </p:sp>
@@ -4535,7 +4507,7 @@
           <a:p>
             <a:pPr algn="l"/>
             <a:r>
-              <a:rPr sz="1600" b="0" i="0" dirty="0">
+              <a:rPr sz="1600" b="0" i="0">
                 <a:solidFill>
                   <a:srgbClr val="B0BCD4"/>
                 </a:solidFill>
@@ -4588,7 +4560,6 @@
           <a:lstStyle/>
           <a:p>
             <a:pPr algn="ctr"/>
-            <a:endParaRPr/>
           </a:p>
         </p:txBody>
       </p:sp>
@@ -4704,7 +4675,6 @@
           <a:lstStyle/>
           <a:p>
             <a:pPr algn="ctr"/>
-            <a:endParaRPr/>
           </a:p>
         </p:txBody>
       </p:sp>
@@ -4820,7 +4790,6 @@
           <a:lstStyle/>
           <a:p>
             <a:pPr algn="ctr"/>
-            <a:endParaRPr/>
           </a:p>
         </p:txBody>
       </p:sp>
@@ -4936,7 +4905,6 @@
           <a:lstStyle/>
           <a:p>
             <a:pPr algn="ctr"/>
-            <a:endParaRPr/>
           </a:p>
         </p:txBody>
       </p:sp>
@@ -5052,7 +5020,6 @@
           <a:lstStyle/>
           <a:p>
             <a:pPr algn="ctr"/>
-            <a:endParaRPr/>
           </a:p>
         </p:txBody>
       </p:sp>
@@ -5168,7 +5135,6 @@
           <a:lstStyle/>
           <a:p>
             <a:pPr algn="ctr"/>
-            <a:endParaRPr/>
           </a:p>
         </p:txBody>
       </p:sp>
@@ -5251,7 +5217,7 @@
 </file>
 
 <file path=ppt/slides/slide12.xml><?xml version="1.0" encoding="utf-8"?>
-<p:sld xmlns:a="http://schemas.openxmlformats.org/drawingml/2006/main" xmlns:r="http://schemas.openxmlformats.org/officeDocument/2006/relationships" xmlns:p="http://schemas.openxmlformats.org/presentationml/2006/main">
+<p:sld xmlns:a="http://schemas.openxmlformats.org/drawingml/2006/main" xmlns:p="http://schemas.openxmlformats.org/presentationml/2006/main" xmlns:r="http://schemas.openxmlformats.org/officeDocument/2006/relationships">
   <p:cSld>
     <p:spTree>
       <p:nvGrpSpPr>
@@ -5259,14 +5225,7 @@
         <p:cNvGrpSpPr/>
         <p:nvPr/>
       </p:nvGrpSpPr>
-      <p:grpSpPr>
-        <a:xfrm>
-          <a:off x="0" y="0"/>
-          <a:ext cx="0" cy="0"/>
-          <a:chOff x="0" y="0"/>
-          <a:chExt cx="0" cy="0"/>
-        </a:xfrm>
-      </p:grpSpPr>
+      <p:grpSpPr/>
       <p:sp>
         <p:nvSpPr>
           <p:cNvPr id="2" name="Rectangle 1"/>
@@ -5275,7 +5234,7 @@
         </p:nvSpPr>
         <p:spPr>
           <a:xfrm>
-            <a:off x="0" y="8626"/>
+            <a:off x="0" y="0"/>
             <a:ext cx="12188952" cy="6858000"/>
           </a:xfrm>
           <a:prstGeom prst="rect">
@@ -5307,7 +5266,6 @@
           <a:lstStyle/>
           <a:p>
             <a:pPr algn="ctr"/>
-            <a:endParaRPr/>
           </a:p>
         </p:txBody>
       </p:sp>
@@ -5351,7 +5309,6 @@
           <a:lstStyle/>
           <a:p>
             <a:pPr algn="ctr"/>
-            <a:endParaRPr/>
           </a:p>
         </p:txBody>
       </p:sp>
@@ -5502,7 +5459,6 @@
           <a:lstStyle/>
           <a:p>
             <a:pPr algn="ctr"/>
-            <a:endParaRPr/>
           </a:p>
         </p:txBody>
       </p:sp>
@@ -5529,377 +5485,35 @@
           <a:lstStyle/>
           <a:p>
             <a:r>
-              <a:rPr sz="950" dirty="0">
+              <a:rPr sz="950">
                 <a:solidFill>
                   <a:srgbClr val="38BDF8"/>
                 </a:solidFill>
                 <a:latin typeface="Consolas"/>
               </a:rPr>
               <a:t># From backend/grantlens_backend/urls.py
-from </a:t>
-            </a:r>
-            <a:r>
-              <a:rPr sz="950" dirty="0" err="1">
-                <a:solidFill>
-                  <a:srgbClr val="38BDF8"/>
-                </a:solidFill>
-                <a:latin typeface="Consolas"/>
-              </a:rPr>
-              <a:t>django.urls</a:t>
-            </a:r>
-            <a:r>
-              <a:rPr sz="950" dirty="0">
-                <a:solidFill>
-                  <a:srgbClr val="38BDF8"/>
-                </a:solidFill>
-                <a:latin typeface="Consolas"/>
-              </a:rPr>
-              <a:t> import path
-from </a:t>
-            </a:r>
-            <a:r>
-              <a:rPr sz="950" dirty="0" err="1">
-                <a:solidFill>
-                  <a:srgbClr val="38BDF8"/>
-                </a:solidFill>
-                <a:latin typeface="Consolas"/>
-              </a:rPr>
-              <a:t>rest_framework.decorators</a:t>
-            </a:r>
-            <a:r>
-              <a:rPr sz="950" dirty="0">
-                <a:solidFill>
-                  <a:srgbClr val="38BDF8"/>
-                </a:solidFill>
-                <a:latin typeface="Consolas"/>
-              </a:rPr>
-              <a:t> import </a:t>
-            </a:r>
-            <a:r>
-              <a:rPr sz="950" dirty="0" err="1">
-                <a:solidFill>
-                  <a:srgbClr val="38BDF8"/>
-                </a:solidFill>
-                <a:latin typeface="Consolas"/>
-              </a:rPr>
-              <a:t>api_view</a:t>
-            </a:r>
-            <a:r>
-              <a:rPr sz="950" dirty="0">
-                <a:solidFill>
-                  <a:srgbClr val="38BDF8"/>
-                </a:solidFill>
-                <a:latin typeface="Consolas"/>
-              </a:rPr>
-              <a:t>   # Restricts HTTP methods
-from </a:t>
-            </a:r>
-            <a:r>
-              <a:rPr sz="950" dirty="0" err="1">
-                <a:solidFill>
-                  <a:srgbClr val="38BDF8"/>
-                </a:solidFill>
-                <a:latin typeface="Consolas"/>
-              </a:rPr>
-              <a:t>rest_framework.response</a:t>
-            </a:r>
-            <a:r>
-              <a:rPr sz="950" dirty="0">
-                <a:solidFill>
-                  <a:srgbClr val="38BDF8"/>
-                </a:solidFill>
-                <a:latin typeface="Consolas"/>
-              </a:rPr>
-              <a:t> import Response     # Auto-serializes </a:t>
-            </a:r>
-            <a:r>
-              <a:rPr sz="950" dirty="0" err="1">
-                <a:solidFill>
-                  <a:srgbClr val="38BDF8"/>
-                </a:solidFill>
-                <a:latin typeface="Consolas"/>
-              </a:rPr>
-              <a:t>dict</a:t>
-            </a:r>
-            <a:r>
-              <a:rPr sz="950" dirty="0">
-                <a:solidFill>
-                  <a:srgbClr val="38BDF8"/>
-                </a:solidFill>
-                <a:latin typeface="Consolas"/>
-              </a:rPr>
-              <a:t> → JSON
+from django.urls import path
+from rest_framework.decorators import api_view   # Restricts HTTP methods
+from rest_framework.response import Response     # Auto-serializes dict → JSON
 from datetime import datetime
 # @api_view(['GET']) — Decorator that:
 #   1. Only allows HTTP GET. Returns 405 for POST/PUT/DELETE automatically.
-#   2. Wraps Django's </a:t>
-            </a:r>
-            <a:r>
-              <a:rPr sz="950" dirty="0" err="1">
-                <a:solidFill>
-                  <a:srgbClr val="38BDF8"/>
-                </a:solidFill>
-                <a:latin typeface="Consolas"/>
-              </a:rPr>
-              <a:t>HttpRequest</a:t>
-            </a:r>
-            <a:r>
-              <a:rPr sz="950" dirty="0">
-                <a:solidFill>
-                  <a:srgbClr val="38BDF8"/>
-                </a:solidFill>
-                <a:latin typeface="Consolas"/>
-              </a:rPr>
-              <a:t> into DRF's enhanced Request object.
+#   2. Wraps Django's HttpRequest into DRF's enhanced Request object.
 #   3. Handles Content-Type negotiation (sends JSON response headers).
 @api_view(['GET'])
-def </a:t>
-            </a:r>
-            <a:r>
-              <a:rPr sz="950" dirty="0" err="1">
-                <a:solidFill>
-                  <a:srgbClr val="38BDF8"/>
-                </a:solidFill>
-                <a:latin typeface="Consolas"/>
-              </a:rPr>
-              <a:t>api_status</a:t>
-            </a:r>
-            <a:r>
-              <a:rPr sz="950" dirty="0">
-                <a:solidFill>
-                  <a:srgbClr val="38BDF8"/>
-                </a:solidFill>
-                <a:latin typeface="Consolas"/>
-              </a:rPr>
-              <a:t>(request):
+def api_status(request):
     payload = {
         "status": "online",
-        "</a:t>
-            </a:r>
-            <a:r>
-              <a:rPr sz="950" dirty="0" err="1">
-                <a:solidFill>
-                  <a:srgbClr val="38BDF8"/>
-                </a:solidFill>
-                <a:latin typeface="Consolas"/>
-              </a:rPr>
-              <a:t>solicitations_count</a:t>
-            </a:r>
-            <a:r>
-              <a:rPr sz="950" dirty="0">
-                <a:solidFill>
-                  <a:srgbClr val="38BDF8"/>
-                </a:solidFill>
-                <a:latin typeface="Consolas"/>
-              </a:rPr>
-              <a:t>": 2,      # Bound to Card 1 in React
-        "</a:t>
-            </a:r>
-            <a:r>
-              <a:rPr sz="950" dirty="0" err="1">
-                <a:solidFill>
-                  <a:srgbClr val="38BDF8"/>
-                </a:solidFill>
-                <a:latin typeface="Consolas"/>
-              </a:rPr>
-              <a:t>proposals_count</a:t>
-            </a:r>
-            <a:r>
-              <a:rPr sz="950" dirty="0">
-                <a:solidFill>
-                  <a:srgbClr val="38BDF8"/>
-                </a:solidFill>
-                <a:latin typeface="Consolas"/>
-              </a:rPr>
-              <a:t>": 3,          # Bound to Card 2 in React
-        "</a:t>
-            </a:r>
-            <a:r>
-              <a:rPr sz="950" dirty="0" err="1">
-                <a:solidFill>
-                  <a:srgbClr val="38BDF8"/>
-                </a:solidFill>
-                <a:latin typeface="Consolas"/>
-              </a:rPr>
-              <a:t>audits_completed</a:t>
-            </a:r>
-            <a:r>
-              <a:rPr sz="950" dirty="0">
-                <a:solidFill>
-                  <a:srgbClr val="38BDF8"/>
-                </a:solidFill>
-                <a:latin typeface="Consolas"/>
-              </a:rPr>
-              <a:t>": 2,         # Bound to Card 3 in React
-        "</a:t>
-            </a:r>
-            <a:r>
-              <a:rPr sz="950" dirty="0" err="1">
-                <a:solidFill>
-                  <a:srgbClr val="38BDF8"/>
-                </a:solidFill>
-                <a:latin typeface="Consolas"/>
-              </a:rPr>
-              <a:t>average_score</a:t>
-            </a:r>
-            <a:r>
-              <a:rPr sz="950" dirty="0">
-                <a:solidFill>
-                  <a:srgbClr val="38BDF8"/>
-                </a:solidFill>
-                <a:latin typeface="Consolas"/>
-              </a:rPr>
-              <a:t>": 96.2,         # Bound to Card 4 in React
-        "timestamp": </a:t>
-            </a:r>
-            <a:r>
-              <a:rPr sz="950" dirty="0" err="1">
-                <a:solidFill>
-                  <a:srgbClr val="38BDF8"/>
-                </a:solidFill>
-                <a:latin typeface="Consolas"/>
-              </a:rPr>
-              <a:t>datetime.now</a:t>
-            </a:r>
-            <a:r>
-              <a:rPr sz="950" dirty="0">
-                <a:solidFill>
-                  <a:srgbClr val="38BDF8"/>
-                </a:solidFill>
-                <a:latin typeface="Consolas"/>
-              </a:rPr>
-              <a:t>().</a:t>
-            </a:r>
-            <a:r>
-              <a:rPr sz="950" dirty="0" err="1">
-                <a:solidFill>
-                  <a:srgbClr val="38BDF8"/>
-                </a:solidFill>
-                <a:latin typeface="Consolas"/>
-              </a:rPr>
-              <a:t>strftime</a:t>
-            </a:r>
-            <a:r>
-              <a:rPr sz="950" dirty="0">
-                <a:solidFill>
-                  <a:srgbClr val="38BDF8"/>
-                </a:solidFill>
-                <a:latin typeface="Consolas"/>
-              </a:rPr>
-              <a:t>("%H:%M:%S")  # Live proof!
+        "solicitations_count": 2,      # Bound to Card 1 in React
+        "proposals_count": 3,          # Bound to Card 2 in React
+        "audits_completed": 2,         # Bound to Card 3 in React
+        "average_score": 96.2,         # Bound to Card 4 in React
+        "timestamp": datetime.now().strftime("%H:%M:%S")  # Live proof!
     }
-    return Response(payload)   # DRF converts </a:t>
-            </a:r>
-            <a:r>
-              <a:rPr sz="950" dirty="0" err="1">
-                <a:solidFill>
-                  <a:srgbClr val="38BDF8"/>
-                </a:solidFill>
-                <a:latin typeface="Consolas"/>
-              </a:rPr>
-              <a:t>dict</a:t>
-            </a:r>
-            <a:r>
-              <a:rPr sz="950" dirty="0">
-                <a:solidFill>
-                  <a:srgbClr val="38BDF8"/>
-                </a:solidFill>
-                <a:latin typeface="Consolas"/>
-              </a:rPr>
-              <a:t> → JSON + HTTP 200
-</a:t>
-            </a:r>
-            <a:r>
-              <a:rPr sz="950" dirty="0" err="1">
-                <a:solidFill>
-                  <a:srgbClr val="38BDF8"/>
-                </a:solidFill>
-                <a:latin typeface="Consolas"/>
-              </a:rPr>
-              <a:t>urlpatterns</a:t>
-            </a:r>
-            <a:r>
-              <a:rPr sz="950" dirty="0">
-                <a:solidFill>
-                  <a:srgbClr val="38BDF8"/>
-                </a:solidFill>
-                <a:latin typeface="Consolas"/>
-              </a:rPr>
-              <a:t> = [
-    path('admin/', </a:t>
-            </a:r>
-            <a:r>
-              <a:rPr sz="950" dirty="0" err="1">
-                <a:solidFill>
-                  <a:srgbClr val="38BDF8"/>
-                </a:solidFill>
-                <a:latin typeface="Consolas"/>
-              </a:rPr>
-              <a:t>admin.site.urls</a:t>
-            </a:r>
-            <a:r>
-              <a:rPr sz="950" dirty="0">
-                <a:solidFill>
-                  <a:srgbClr val="38BDF8"/>
-                </a:solidFill>
-                <a:latin typeface="Consolas"/>
-              </a:rPr>
-              <a:t>),
-    path('</a:t>
-            </a:r>
-            <a:r>
-              <a:rPr sz="950" dirty="0" err="1">
-                <a:solidFill>
-                  <a:srgbClr val="38BDF8"/>
-                </a:solidFill>
-                <a:latin typeface="Consolas"/>
-              </a:rPr>
-              <a:t>api</a:t>
-            </a:r>
-            <a:r>
-              <a:rPr sz="950" dirty="0">
-                <a:solidFill>
-                  <a:srgbClr val="38BDF8"/>
-                </a:solidFill>
-                <a:latin typeface="Consolas"/>
-              </a:rPr>
-              <a:t>/status/', </a:t>
-            </a:r>
-            <a:r>
-              <a:rPr sz="950" dirty="0" err="1">
-                <a:solidFill>
-                  <a:srgbClr val="38BDF8"/>
-                </a:solidFill>
-                <a:latin typeface="Consolas"/>
-              </a:rPr>
-              <a:t>api_status</a:t>
-            </a:r>
-            <a:r>
-              <a:rPr sz="950" dirty="0">
-                <a:solidFill>
-                  <a:srgbClr val="38BDF8"/>
-                </a:solidFill>
-                <a:latin typeface="Consolas"/>
-              </a:rPr>
-              <a:t>, name='</a:t>
-            </a:r>
-            <a:r>
-              <a:rPr sz="950" dirty="0" err="1">
-                <a:solidFill>
-                  <a:srgbClr val="38BDF8"/>
-                </a:solidFill>
-                <a:latin typeface="Consolas"/>
-              </a:rPr>
-              <a:t>api_status</a:t>
-            </a:r>
-            <a:r>
-              <a:rPr sz="950" dirty="0">
-                <a:solidFill>
-                  <a:srgbClr val="38BDF8"/>
-                </a:solidFill>
-                <a:latin typeface="Consolas"/>
-              </a:rPr>
-              <a:t>'),  # Our endpoint
+    return Response(payload)   # DRF converts dict → JSON + HTTP 200
+urlpatterns = [
+    path('admin/', admin.site.urls),
+    path('api/status/', api_status, name='api_status'),  # Our endpoint
 ]</a:t>
             </a:r>
           </a:p>
@@ -5947,7 +5561,6 @@
           <a:lstStyle/>
           <a:p>
             <a:pPr algn="ctr"/>
-            <a:endParaRPr/>
           </a:p>
         </p:txBody>
       </p:sp>
@@ -6064,7 +5677,6 @@
           <a:lstStyle/>
           <a:p>
             <a:pPr algn="ctr"/>
-            <a:endParaRPr/>
           </a:p>
         </p:txBody>
       </p:sp>
@@ -6181,7 +5793,6 @@
           <a:lstStyle/>
           <a:p>
             <a:pPr algn="ctr"/>
-            <a:endParaRPr/>
           </a:p>
         </p:txBody>
       </p:sp>
@@ -6264,7 +5875,7 @@
 </file>
 
 <file path=ppt/slides/slide13.xml><?xml version="1.0" encoding="utf-8"?>
-<p:sld xmlns:a="http://schemas.openxmlformats.org/drawingml/2006/main" xmlns:r="http://schemas.openxmlformats.org/officeDocument/2006/relationships" xmlns:p="http://schemas.openxmlformats.org/presentationml/2006/main">
+<p:sld xmlns:a="http://schemas.openxmlformats.org/drawingml/2006/main" xmlns:p="http://schemas.openxmlformats.org/presentationml/2006/main" xmlns:r="http://schemas.openxmlformats.org/officeDocument/2006/relationships">
   <p:cSld>
     <p:spTree>
       <p:nvGrpSpPr>
@@ -6272,14 +5883,7 @@
         <p:cNvGrpSpPr/>
         <p:nvPr/>
       </p:nvGrpSpPr>
-      <p:grpSpPr>
-        <a:xfrm>
-          <a:off x="0" y="0"/>
-          <a:ext cx="0" cy="0"/>
-          <a:chOff x="0" y="0"/>
-          <a:chExt cx="0" cy="0"/>
-        </a:xfrm>
-      </p:grpSpPr>
+      <p:grpSpPr/>
       <p:sp>
         <p:nvSpPr>
           <p:cNvPr id="2" name="Rectangle 1"/>
@@ -6320,7 +5924,6 @@
           <a:lstStyle/>
           <a:p>
             <a:pPr algn="ctr"/>
-            <a:endParaRPr/>
           </a:p>
         </p:txBody>
       </p:sp>
@@ -6364,7 +5967,6 @@
           <a:lstStyle/>
           <a:p>
             <a:pPr algn="ctr"/>
-            <a:endParaRPr/>
           </a:p>
         </p:txBody>
       </p:sp>
@@ -6515,7 +6117,6 @@
           <a:lstStyle/>
           <a:p>
             <a:pPr algn="ctr"/>
-            <a:endParaRPr/>
           </a:p>
         </p:txBody>
       </p:sp>
@@ -6723,7 +6324,6 @@
           <a:lstStyle/>
           <a:p>
             <a:pPr algn="ctr"/>
-            <a:endParaRPr/>
           </a:p>
         </p:txBody>
       </p:sp>
@@ -6823,7 +6423,7 @@
 </file>
 
 <file path=ppt/slides/slide14.xml><?xml version="1.0" encoding="utf-8"?>
-<p:sld xmlns:a="http://schemas.openxmlformats.org/drawingml/2006/main" xmlns:r="http://schemas.openxmlformats.org/officeDocument/2006/relationships" xmlns:p="http://schemas.openxmlformats.org/presentationml/2006/main">
+<p:sld xmlns:a="http://schemas.openxmlformats.org/drawingml/2006/main" xmlns:p="http://schemas.openxmlformats.org/presentationml/2006/main" xmlns:r="http://schemas.openxmlformats.org/officeDocument/2006/relationships">
   <p:cSld>
     <p:spTree>
       <p:nvGrpSpPr>
@@ -6831,14 +6431,7 @@
         <p:cNvGrpSpPr/>
         <p:nvPr/>
       </p:nvGrpSpPr>
-      <p:grpSpPr>
-        <a:xfrm>
-          <a:off x="0" y="0"/>
-          <a:ext cx="0" cy="0"/>
-          <a:chOff x="0" y="0"/>
-          <a:chExt cx="0" cy="0"/>
-        </a:xfrm>
-      </p:grpSpPr>
+      <p:grpSpPr/>
       <p:sp>
         <p:nvSpPr>
           <p:cNvPr id="2" name="Rectangle 1"/>
@@ -6847,7 +6440,7 @@
         </p:nvSpPr>
         <p:spPr>
           <a:xfrm>
-            <a:off x="0" y="8626"/>
+            <a:off x="0" y="0"/>
             <a:ext cx="12188952" cy="6858000"/>
           </a:xfrm>
           <a:prstGeom prst="rect">
@@ -6879,7 +6472,6 @@
           <a:lstStyle/>
           <a:p>
             <a:pPr algn="ctr"/>
-            <a:endParaRPr/>
           </a:p>
         </p:txBody>
       </p:sp>
@@ -6923,7 +6515,6 @@
           <a:lstStyle/>
           <a:p>
             <a:pPr algn="ctr"/>
-            <a:endParaRPr/>
           </a:p>
         </p:txBody>
       </p:sp>
@@ -7074,7 +6665,6 @@
           <a:lstStyle/>
           <a:p>
             <a:pPr algn="ctr"/>
-            <a:endParaRPr/>
           </a:p>
         </p:txBody>
       </p:sp>
@@ -7191,7 +6781,6 @@
           <a:lstStyle/>
           <a:p>
             <a:pPr algn="ctr"/>
-            <a:endParaRPr/>
           </a:p>
         </p:txBody>
       </p:sp>
@@ -7218,7 +6807,7 @@
           <a:lstStyle/>
           <a:p>
             <a:r>
-              <a:rPr sz="950" dirty="0">
+              <a:rPr sz="950">
                 <a:solidFill>
                   <a:srgbClr val="38BDF8"/>
                 </a:solidFill>
@@ -7227,143 +6816,17 @@
               <a:t># From backend/grantlens_backend/settings.py
 INSTALLED_APPS = [
     ...
-    '</a:t>
-            </a:r>
-            <a:r>
-              <a:rPr sz="950" dirty="0" err="1">
-                <a:solidFill>
-                  <a:srgbClr val="38BDF8"/>
-                </a:solidFill>
-                <a:latin typeface="Consolas"/>
-              </a:rPr>
-              <a:t>corsheaders</a:t>
-            </a:r>
-            <a:r>
-              <a:rPr sz="950" dirty="0">
-                <a:solidFill>
-                  <a:srgbClr val="38BDF8"/>
-                </a:solidFill>
-                <a:latin typeface="Consolas"/>
-              </a:rPr>
-              <a:t>',          # Step 1: Install the CORS app
-    '</a:t>
-            </a:r>
-            <a:r>
-              <a:rPr sz="950" dirty="0" err="1">
-                <a:solidFill>
-                  <a:srgbClr val="38BDF8"/>
-                </a:solidFill>
-                <a:latin typeface="Consolas"/>
-              </a:rPr>
-              <a:t>rest_framework</a:t>
-            </a:r>
-            <a:r>
-              <a:rPr sz="950" dirty="0">
-                <a:solidFill>
-                  <a:srgbClr val="38BDF8"/>
-                </a:solidFill>
-                <a:latin typeface="Consolas"/>
-              </a:rPr>
-              <a:t>',
+    'corsheaders',          # Step 1: Install the CORS app
+    'rest_framework',
 ]
-# Step 2: Add </a:t>
-            </a:r>
-            <a:r>
-              <a:rPr sz="950" dirty="0" err="1">
-                <a:solidFill>
-                  <a:srgbClr val="38BDF8"/>
-                </a:solidFill>
-                <a:latin typeface="Consolas"/>
-              </a:rPr>
-              <a:t>CorsMiddleware</a:t>
-            </a:r>
-            <a:r>
-              <a:rPr sz="950" dirty="0">
-                <a:solidFill>
-                  <a:srgbClr val="38BDF8"/>
-                </a:solidFill>
-                <a:latin typeface="Consolas"/>
-              </a:rPr>
-              <a:t> at index 0 (THE VERY TOP — this is critical!)
+# Step 2: Add CorsMiddleware at index 0 (THE VERY TOP — this is critical!)
 # Django processes middleware top-to-bottom.
-# If </a:t>
-            </a:r>
-            <a:r>
-              <a:rPr sz="950" dirty="0" err="1">
-                <a:solidFill>
-                  <a:srgbClr val="38BDF8"/>
-                </a:solidFill>
-                <a:latin typeface="Consolas"/>
-              </a:rPr>
-              <a:t>CorsMiddleware</a:t>
-            </a:r>
-            <a:r>
-              <a:rPr sz="950" dirty="0">
-                <a:solidFill>
-                  <a:srgbClr val="38BDF8"/>
-                </a:solidFill>
-                <a:latin typeface="Consolas"/>
-              </a:rPr>
-              <a:t> is not first, CSRF or Auth middleware rejects the
+# If CorsMiddleware is not first, CSRF or Auth middleware rejects the
 # preflight OPTIONS request before CORS headers can be added.
 MIDDLEWARE = [
-    '</a:t>
-            </a:r>
-            <a:r>
-              <a:rPr sz="950" dirty="0" err="1">
-                <a:solidFill>
-                  <a:srgbClr val="38BDF8"/>
-                </a:solidFill>
-                <a:latin typeface="Consolas"/>
-              </a:rPr>
-              <a:t>corsheaders.middleware.CorsMiddleware</a:t>
-            </a:r>
-            <a:r>
-              <a:rPr sz="950" dirty="0">
-                <a:solidFill>
-                  <a:srgbClr val="38BDF8"/>
-                </a:solidFill>
-                <a:latin typeface="Consolas"/>
-              </a:rPr>
-              <a:t>',   # ← Must be index 0!
-    '</a:t>
-            </a:r>
-            <a:r>
-              <a:rPr sz="950" dirty="0" err="1">
-                <a:solidFill>
-                  <a:srgbClr val="38BDF8"/>
-                </a:solidFill>
-                <a:latin typeface="Consolas"/>
-              </a:rPr>
-              <a:t>django.middleware.security.SecurityMiddleware</a:t>
-            </a:r>
-            <a:r>
-              <a:rPr sz="950" dirty="0">
-                <a:solidFill>
-                  <a:srgbClr val="38BDF8"/>
-                </a:solidFill>
-                <a:latin typeface="Consolas"/>
-              </a:rPr>
-              <a:t>',
-    '</a:t>
-            </a:r>
-            <a:r>
-              <a:rPr sz="950" dirty="0" err="1">
-                <a:solidFill>
-                  <a:srgbClr val="38BDF8"/>
-                </a:solidFill>
-                <a:latin typeface="Consolas"/>
-              </a:rPr>
-              <a:t>django.contrib.sessions.middleware.SessionMiddleware</a:t>
-            </a:r>
-            <a:r>
-              <a:rPr sz="950" dirty="0">
-                <a:solidFill>
-                  <a:srgbClr val="38BDF8"/>
-                </a:solidFill>
-                <a:latin typeface="Consolas"/>
-              </a:rPr>
-              <a:t>',
+    'corsheaders.middleware.CorsMiddleware',   # ← Must be index 0!
+    'django.middleware.security.SecurityMiddleware',
+    'django.contrib.sessions.middleware.SessionMiddleware',
     ...
 ]
 # Step 3: Allow all origins during development
@@ -7416,7 +6879,6 @@
           <a:lstStyle/>
           <a:p>
             <a:pPr algn="ctr"/>
-            <a:endParaRPr/>
           </a:p>
         </p:txBody>
       </p:sp>
@@ -7532,7 +6994,6 @@
           <a:lstStyle/>
           <a:p>
             <a:pPr algn="ctr"/>
-            <a:endParaRPr/>
           </a:p>
         </p:txBody>
       </p:sp>
@@ -7648,7 +7109,6 @@
           <a:lstStyle/>
           <a:p>
             <a:pPr algn="ctr"/>
-            <a:endParaRPr/>
           </a:p>
         </p:txBody>
       </p:sp>
@@ -7764,7 +7224,6 @@
           <a:lstStyle/>
           <a:p>
             <a:pPr algn="ctr"/>
-            <a:endParaRPr/>
           </a:p>
         </p:txBody>
       </p:sp>
@@ -7847,7 +7306,7 @@
 </file>
 
 <file path=ppt/slides/slide15.xml><?xml version="1.0" encoding="utf-8"?>
-<p:sld xmlns:a="http://schemas.openxmlformats.org/drawingml/2006/main" xmlns:r="http://schemas.openxmlformats.org/officeDocument/2006/relationships" xmlns:p="http://schemas.openxmlformats.org/presentationml/2006/main">
+<p:sld xmlns:a="http://schemas.openxmlformats.org/drawingml/2006/main" xmlns:p="http://schemas.openxmlformats.org/presentationml/2006/main" xmlns:r="http://schemas.openxmlformats.org/officeDocument/2006/relationships">
   <p:cSld>
     <p:spTree>
       <p:nvGrpSpPr>
@@ -7855,14 +7314,7 @@
         <p:cNvGrpSpPr/>
         <p:nvPr/>
       </p:nvGrpSpPr>
-      <p:grpSpPr>
-        <a:xfrm>
-          <a:off x="0" y="0"/>
-          <a:ext cx="0" cy="0"/>
-          <a:chOff x="0" y="0"/>
-          <a:chExt cx="0" cy="0"/>
-        </a:xfrm>
-      </p:grpSpPr>
+      <p:grpSpPr/>
       <p:sp>
         <p:nvSpPr>
           <p:cNvPr id="2" name="Rectangle 1"/>
@@ -7903,7 +7355,6 @@
           <a:lstStyle/>
           <a:p>
             <a:pPr algn="ctr"/>
-            <a:endParaRPr/>
           </a:p>
         </p:txBody>
       </p:sp>
@@ -7947,7 +7398,6 @@
           <a:lstStyle/>
           <a:p>
             <a:pPr algn="ctr"/>
-            <a:endParaRPr/>
           </a:p>
         </p:txBody>
       </p:sp>
@@ -8098,7 +7548,6 @@
           <a:lstStyle/>
           <a:p>
             <a:pPr algn="ctr"/>
-            <a:endParaRPr/>
           </a:p>
         </p:txBody>
       </p:sp>
@@ -8196,7 +7645,6 @@
           <a:lstStyle/>
           <a:p>
             <a:pPr algn="ctr"/>
-            <a:endParaRPr/>
           </a:p>
         </p:txBody>
       </p:sp>
@@ -8312,7 +7760,6 @@
           <a:lstStyle/>
           <a:p>
             <a:pPr algn="ctr"/>
-            <a:endParaRPr/>
           </a:p>
         </p:txBody>
       </p:sp>
@@ -8428,7 +7875,6 @@
           <a:lstStyle/>
           <a:p>
             <a:pPr algn="ctr"/>
-            <a:endParaRPr/>
           </a:p>
         </p:txBody>
       </p:sp>
@@ -8544,7 +7990,6 @@
           <a:lstStyle/>
           <a:p>
             <a:pPr algn="ctr"/>
-            <a:endParaRPr/>
           </a:p>
         </p:txBody>
       </p:sp>
@@ -8627,7 +8072,7 @@
 </file>
 
 <file path=ppt/slides/slide16.xml><?xml version="1.0" encoding="utf-8"?>
-<p:sld xmlns:a="http://schemas.openxmlformats.org/drawingml/2006/main" xmlns:r="http://schemas.openxmlformats.org/officeDocument/2006/relationships" xmlns:p="http://schemas.openxmlformats.org/presentationml/2006/main">
+<p:sld xmlns:a="http://schemas.openxmlformats.org/drawingml/2006/main" xmlns:p="http://schemas.openxmlformats.org/presentationml/2006/main" xmlns:r="http://schemas.openxmlformats.org/officeDocument/2006/relationships">
   <p:cSld>
     <p:spTree>
       <p:nvGrpSpPr>
@@ -8635,14 +8080,7 @@
         <p:cNvGrpSpPr/>
         <p:nvPr/>
       </p:nvGrpSpPr>
-      <p:grpSpPr>
-        <a:xfrm>
-          <a:off x="0" y="0"/>
-          <a:ext cx="0" cy="0"/>
-          <a:chOff x="0" y="0"/>
-          <a:chExt cx="0" cy="0"/>
-        </a:xfrm>
-      </p:grpSpPr>
+      <p:grpSpPr/>
       <p:sp>
         <p:nvSpPr>
           <p:cNvPr id="2" name="Rectangle 1"/>
@@ -8683,7 +8121,6 @@
           <a:lstStyle/>
           <a:p>
             <a:pPr algn="ctr"/>
-            <a:endParaRPr/>
           </a:p>
         </p:txBody>
       </p:sp>
@@ -8727,7 +8164,6 @@
           <a:lstStyle/>
           <a:p>
             <a:pPr algn="ctr"/>
-            <a:endParaRPr/>
           </a:p>
         </p:txBody>
       </p:sp>
@@ -8878,7 +8314,6 @@
           <a:lstStyle/>
           <a:p>
             <a:pPr algn="ctr"/>
-            <a:endParaRPr/>
           </a:p>
         </p:txBody>
       </p:sp>
@@ -8982,7 +8417,6 @@
           <a:lstStyle/>
           <a:p>
             <a:pPr algn="ctr"/>
-            <a:endParaRPr/>
           </a:p>
         </p:txBody>
       </p:sp>
@@ -9249,7 +8683,7 @@
 </file>
 
 <file path=ppt/slides/slide17.xml><?xml version="1.0" encoding="utf-8"?>
-<p:sld xmlns:a="http://schemas.openxmlformats.org/drawingml/2006/main" xmlns:r="http://schemas.openxmlformats.org/officeDocument/2006/relationships" xmlns:p="http://schemas.openxmlformats.org/presentationml/2006/main">
+<p:sld xmlns:a="http://schemas.openxmlformats.org/drawingml/2006/main" xmlns:p="http://schemas.openxmlformats.org/presentationml/2006/main" xmlns:r="http://schemas.openxmlformats.org/officeDocument/2006/relationships">
   <p:cSld>
     <p:spTree>
       <p:nvGrpSpPr>
@@ -9257,14 +8691,7 @@
         <p:cNvGrpSpPr/>
         <p:nvPr/>
       </p:nvGrpSpPr>
-      <p:grpSpPr>
-        <a:xfrm>
-          <a:off x="0" y="0"/>
-          <a:ext cx="0" cy="0"/>
-          <a:chOff x="0" y="0"/>
-          <a:chExt cx="0" cy="0"/>
-        </a:xfrm>
-      </p:grpSpPr>
+      <p:grpSpPr/>
       <p:sp>
         <p:nvSpPr>
           <p:cNvPr id="2" name="Rectangle 1"/>
@@ -9305,7 +8732,6 @@
           <a:lstStyle/>
           <a:p>
             <a:pPr algn="ctr"/>
-            <a:endParaRPr/>
           </a:p>
         </p:txBody>
       </p:sp>
@@ -9349,7 +8775,6 @@
           <a:lstStyle/>
           <a:p>
             <a:pPr algn="ctr"/>
-            <a:endParaRPr/>
           </a:p>
         </p:txBody>
       </p:sp>
@@ -9500,7 +8925,6 @@
           <a:lstStyle/>
           <a:p>
             <a:pPr algn="ctr"/>
-            <a:endParaRPr/>
           </a:p>
         </p:txBody>
       </p:sp>
@@ -9621,7 +9045,6 @@
           <a:lstStyle/>
           <a:p>
             <a:pPr algn="ctr"/>
-            <a:endParaRPr/>
           </a:p>
         </p:txBody>
       </p:sp>
@@ -10019,7 +9442,7 @@
 </file>
 
 <file path=ppt/slides/slide18.xml><?xml version="1.0" encoding="utf-8"?>
-<p:sld xmlns:a="http://schemas.openxmlformats.org/drawingml/2006/main" xmlns:r="http://schemas.openxmlformats.org/officeDocument/2006/relationships" xmlns:p="http://schemas.openxmlformats.org/presentationml/2006/main">
+<p:sld xmlns:a="http://schemas.openxmlformats.org/drawingml/2006/main" xmlns:p="http://schemas.openxmlformats.org/presentationml/2006/main" xmlns:r="http://schemas.openxmlformats.org/officeDocument/2006/relationships">
   <p:cSld>
     <p:spTree>
       <p:nvGrpSpPr>
@@ -10027,14 +9450,7 @@
         <p:cNvGrpSpPr/>
         <p:nvPr/>
       </p:nvGrpSpPr>
-      <p:grpSpPr>
-        <a:xfrm>
-          <a:off x="0" y="0"/>
-          <a:ext cx="0" cy="0"/>
-          <a:chOff x="0" y="0"/>
-          <a:chExt cx="0" cy="0"/>
-        </a:xfrm>
-      </p:grpSpPr>
+      <p:grpSpPr/>
       <p:sp>
         <p:nvSpPr>
           <p:cNvPr id="2" name="Rectangle 1"/>
@@ -10075,7 +9491,6 @@
           <a:lstStyle/>
           <a:p>
             <a:pPr algn="ctr"/>
-            <a:endParaRPr/>
           </a:p>
         </p:txBody>
       </p:sp>
@@ -10119,7 +9534,6 @@
           <a:lstStyle/>
           <a:p>
             <a:pPr algn="ctr"/>
-            <a:endParaRPr/>
           </a:p>
         </p:txBody>
       </p:sp>
@@ -10270,7 +9684,6 @@
           <a:lstStyle/>
           <a:p>
             <a:pPr algn="ctr"/>
-            <a:endParaRPr/>
           </a:p>
         </p:txBody>
       </p:sp>
@@ -10394,7 +9807,6 @@
           <a:lstStyle/>
           <a:p>
             <a:pPr algn="ctr"/>
-            <a:endParaRPr/>
           </a:p>
         </p:txBody>
       </p:sp>
@@ -10499,7 +9911,7 @@
           <a:p>
             <a:pPr algn="l"/>
             <a:r>
-              <a:rPr sz="1200" b="0" i="1" dirty="0">
+              <a:rPr sz="1200" b="0" i="1">
                 <a:solidFill>
                   <a:srgbClr val="64748B"/>
                 </a:solidFill>
@@ -10519,7 +9931,7 @@
 </file>
 
 <file path=ppt/slides/slide19.xml><?xml version="1.0" encoding="utf-8"?>
-<p:sld xmlns:a="http://schemas.openxmlformats.org/drawingml/2006/main" xmlns:r="http://schemas.openxmlformats.org/officeDocument/2006/relationships" xmlns:p="http://schemas.openxmlformats.org/presentationml/2006/main">
+<p:sld xmlns:a="http://schemas.openxmlformats.org/drawingml/2006/main" xmlns:p="http://schemas.openxmlformats.org/presentationml/2006/main" xmlns:r="http://schemas.openxmlformats.org/officeDocument/2006/relationships">
   <p:cSld>
     <p:spTree>
       <p:nvGrpSpPr>
@@ -10527,14 +9939,7 @@
         <p:cNvGrpSpPr/>
         <p:nvPr/>
       </p:nvGrpSpPr>
-      <p:grpSpPr>
-        <a:xfrm>
-          <a:off x="0" y="0"/>
-          <a:ext cx="0" cy="0"/>
-          <a:chOff x="0" y="0"/>
-          <a:chExt cx="0" cy="0"/>
-        </a:xfrm>
-      </p:grpSpPr>
+      <p:grpSpPr/>
       <p:sp>
         <p:nvSpPr>
           <p:cNvPr id="2" name="Rectangle 1"/>
@@ -10575,7 +9980,6 @@
           <a:lstStyle/>
           <a:p>
             <a:pPr algn="ctr"/>
-            <a:endParaRPr/>
           </a:p>
         </p:txBody>
       </p:sp>
@@ -10619,7 +10023,6 @@
           <a:lstStyle/>
           <a:p>
             <a:pPr algn="ctr"/>
-            <a:endParaRPr/>
           </a:p>
         </p:txBody>
       </p:sp>
@@ -10770,7 +10173,6 @@
           <a:lstStyle/>
           <a:p>
             <a:pPr algn="ctr"/>
-            <a:endParaRPr/>
           </a:p>
         </p:txBody>
       </p:sp>
@@ -10892,7 +10294,6 @@
           <a:lstStyle/>
           <a:p>
             <a:pPr algn="ctr"/>
-            <a:endParaRPr/>
           </a:p>
         </p:txBody>
       </p:sp>
@@ -11015,7 +10416,6 @@
           <a:lstStyle/>
           <a:p>
             <a:pPr algn="ctr"/>
-            <a:endParaRPr/>
           </a:p>
         </p:txBody>
       </p:sp>
@@ -11131,7 +10531,6 @@
           <a:lstStyle/>
           <a:p>
             <a:pPr algn="ctr"/>
-            <a:endParaRPr/>
           </a:p>
         </p:txBody>
       </p:sp>
@@ -11247,7 +10646,6 @@
           <a:lstStyle/>
           <a:p>
             <a:pPr algn="ctr"/>
-            <a:endParaRPr/>
           </a:p>
         </p:txBody>
       </p:sp>
@@ -11363,7 +10761,6 @@
           <a:lstStyle/>
           <a:p>
             <a:pPr algn="ctr"/>
-            <a:endParaRPr/>
           </a:p>
         </p:txBody>
       </p:sp>
@@ -11446,7 +10843,7 @@
 </file>
 
 <file path=ppt/slides/slide2.xml><?xml version="1.0" encoding="utf-8"?>
-<p:sld xmlns:a="http://schemas.openxmlformats.org/drawingml/2006/main" xmlns:r="http://schemas.openxmlformats.org/officeDocument/2006/relationships" xmlns:p="http://schemas.openxmlformats.org/presentationml/2006/main">
+<p:sld xmlns:a="http://schemas.openxmlformats.org/drawingml/2006/main" xmlns:p="http://schemas.openxmlformats.org/presentationml/2006/main" xmlns:r="http://schemas.openxmlformats.org/officeDocument/2006/relationships">
   <p:cSld>
     <p:spTree>
       <p:nvGrpSpPr>
@@ -11454,14 +10851,7 @@
         <p:cNvGrpSpPr/>
         <p:nvPr/>
       </p:nvGrpSpPr>
-      <p:grpSpPr>
-        <a:xfrm>
-          <a:off x="0" y="0"/>
-          <a:ext cx="0" cy="0"/>
-          <a:chOff x="0" y="0"/>
-          <a:chExt cx="0" cy="0"/>
-        </a:xfrm>
-      </p:grpSpPr>
+      <p:grpSpPr/>
       <p:sp>
         <p:nvSpPr>
           <p:cNvPr id="2" name="Rectangle 1"/>
@@ -11502,7 +10892,6 @@
           <a:lstStyle/>
           <a:p>
             <a:pPr algn="ctr"/>
-            <a:endParaRPr/>
           </a:p>
         </p:txBody>
       </p:sp>
@@ -11546,7 +10935,6 @@
           <a:lstStyle/>
           <a:p>
             <a:pPr algn="ctr"/>
-            <a:endParaRPr/>
           </a:p>
         </p:txBody>
       </p:sp>
@@ -11697,7 +11085,6 @@
           <a:lstStyle/>
           <a:p>
             <a:pPr algn="ctr"/>
-            <a:endParaRPr/>
           </a:p>
         </p:txBody>
       </p:sp>
@@ -11813,7 +11200,6 @@
           <a:lstStyle/>
           <a:p>
             <a:pPr algn="ctr"/>
-            <a:endParaRPr/>
           </a:p>
         </p:txBody>
       </p:sp>
@@ -11929,7 +11315,6 @@
           <a:lstStyle/>
           <a:p>
             <a:pPr algn="ctr"/>
-            <a:endParaRPr/>
           </a:p>
         </p:txBody>
       </p:sp>
@@ -12045,7 +11430,6 @@
           <a:lstStyle/>
           <a:p>
             <a:pPr algn="ctr"/>
-            <a:endParaRPr/>
           </a:p>
         </p:txBody>
       </p:sp>
@@ -12128,7 +11512,7 @@
 </file>
 
 <file path=ppt/slides/slide20.xml><?xml version="1.0" encoding="utf-8"?>
-<p:sld xmlns:a="http://schemas.openxmlformats.org/drawingml/2006/main" xmlns:r="http://schemas.openxmlformats.org/officeDocument/2006/relationships" xmlns:p="http://schemas.openxmlformats.org/presentationml/2006/main">
+<p:sld xmlns:a="http://schemas.openxmlformats.org/drawingml/2006/main" xmlns:p="http://schemas.openxmlformats.org/presentationml/2006/main" xmlns:r="http://schemas.openxmlformats.org/officeDocument/2006/relationships">
   <p:cSld>
     <p:spTree>
       <p:nvGrpSpPr>
@@ -12136,14 +11520,7 @@
         <p:cNvGrpSpPr/>
         <p:nvPr/>
       </p:nvGrpSpPr>
-      <p:grpSpPr>
-        <a:xfrm>
-          <a:off x="0" y="0"/>
-          <a:ext cx="0" cy="0"/>
-          <a:chOff x="0" y="0"/>
-          <a:chExt cx="0" cy="0"/>
-        </a:xfrm>
-      </p:grpSpPr>
+      <p:grpSpPr/>
       <p:sp>
         <p:nvSpPr>
           <p:cNvPr id="2" name="Rectangle 1"/>
@@ -12184,7 +11561,6 @@
           <a:lstStyle/>
           <a:p>
             <a:pPr algn="ctr"/>
-            <a:endParaRPr/>
           </a:p>
         </p:txBody>
       </p:sp>
@@ -12228,7 +11604,6 @@
           <a:lstStyle/>
           <a:p>
             <a:pPr algn="ctr"/>
-            <a:endParaRPr/>
           </a:p>
         </p:txBody>
       </p:sp>
@@ -12379,7 +11754,6 @@
           <a:lstStyle/>
           <a:p>
             <a:pPr algn="ctr"/>
-            <a:endParaRPr/>
           </a:p>
         </p:txBody>
       </p:sp>
@@ -12495,7 +11869,6 @@
           <a:lstStyle/>
           <a:p>
             <a:pPr algn="ctr"/>
-            <a:endParaRPr/>
           </a:p>
         </p:txBody>
       </p:sp>
@@ -12611,7 +11984,6 @@
           <a:lstStyle/>
           <a:p>
             <a:pPr algn="ctr"/>
-            <a:endParaRPr/>
           </a:p>
         </p:txBody>
       </p:sp>
@@ -12727,7 +12099,6 @@
           <a:lstStyle/>
           <a:p>
             <a:pPr algn="ctr"/>
-            <a:endParaRPr/>
           </a:p>
         </p:txBody>
       </p:sp>
@@ -12843,7 +12214,6 @@
           <a:lstStyle/>
           <a:p>
             <a:pPr algn="ctr"/>
-            <a:endParaRPr/>
           </a:p>
         </p:txBody>
       </p:sp>
@@ -12959,7 +12329,6 @@
           <a:lstStyle/>
           <a:p>
             <a:pPr algn="ctr"/>
-            <a:endParaRPr/>
           </a:p>
         </p:txBody>
       </p:sp>
@@ -13075,7 +12444,6 @@
           <a:lstStyle/>
           <a:p>
             <a:pPr algn="ctr"/>
-            <a:endParaRPr/>
           </a:p>
         </p:txBody>
       </p:sp>
@@ -13191,7 +12559,6 @@
           <a:lstStyle/>
           <a:p>
             <a:pPr algn="ctr"/>
-            <a:endParaRPr/>
           </a:p>
         </p:txBody>
       </p:sp>
@@ -13274,7 +12641,7 @@
 </file>
 
 <file path=ppt/slides/slide21.xml><?xml version="1.0" encoding="utf-8"?>
-<p:sld xmlns:a="http://schemas.openxmlformats.org/drawingml/2006/main" xmlns:r="http://schemas.openxmlformats.org/officeDocument/2006/relationships" xmlns:p="http://schemas.openxmlformats.org/presentationml/2006/main">
+<p:sld xmlns:a="http://schemas.openxmlformats.org/drawingml/2006/main" xmlns:p="http://schemas.openxmlformats.org/presentationml/2006/main" xmlns:r="http://schemas.openxmlformats.org/officeDocument/2006/relationships">
   <p:cSld>
     <p:spTree>
       <p:nvGrpSpPr>
@@ -13282,14 +12649,7 @@
         <p:cNvGrpSpPr/>
         <p:nvPr/>
       </p:nvGrpSpPr>
-      <p:grpSpPr>
-        <a:xfrm>
-          <a:off x="0" y="0"/>
-          <a:ext cx="0" cy="0"/>
-          <a:chOff x="0" y="0"/>
-          <a:chExt cx="0" cy="0"/>
-        </a:xfrm>
-      </p:grpSpPr>
+      <p:grpSpPr/>
       <p:sp>
         <p:nvSpPr>
           <p:cNvPr id="2" name="Rectangle 1"/>
@@ -13330,7 +12690,6 @@
           <a:lstStyle/>
           <a:p>
             <a:pPr algn="ctr"/>
-            <a:endParaRPr/>
           </a:p>
         </p:txBody>
       </p:sp>
@@ -13374,7 +12733,6 @@
           <a:lstStyle/>
           <a:p>
             <a:pPr algn="ctr"/>
-            <a:endParaRPr/>
           </a:p>
         </p:txBody>
       </p:sp>
@@ -13525,7 +12883,6 @@
           <a:lstStyle/>
           <a:p>
             <a:pPr algn="ctr"/>
-            <a:endParaRPr/>
           </a:p>
         </p:txBody>
       </p:sp>
@@ -13710,7 +13067,6 @@
           <a:lstStyle/>
           <a:p>
             <a:pPr algn="ctr"/>
-            <a:endParaRPr/>
           </a:p>
         </p:txBody>
       </p:sp>
@@ -13895,7 +13251,6 @@
           <a:lstStyle/>
           <a:p>
             <a:pPr algn="ctr"/>
-            <a:endParaRPr/>
           </a:p>
         </p:txBody>
       </p:sp>
@@ -14080,7 +13435,6 @@
           <a:lstStyle/>
           <a:p>
             <a:pPr algn="ctr"/>
-            <a:endParaRPr/>
           </a:p>
         </p:txBody>
       </p:sp>
@@ -14232,7 +13586,7 @@
 </file>
 
 <file path=ppt/slides/slide22.xml><?xml version="1.0" encoding="utf-8"?>
-<p:sld xmlns:a="http://schemas.openxmlformats.org/drawingml/2006/main" xmlns:r="http://schemas.openxmlformats.org/officeDocument/2006/relationships" xmlns:p="http://schemas.openxmlformats.org/presentationml/2006/main">
+<p:sld xmlns:a="http://schemas.openxmlformats.org/drawingml/2006/main" xmlns:p="http://schemas.openxmlformats.org/presentationml/2006/main" xmlns:r="http://schemas.openxmlformats.org/officeDocument/2006/relationships">
   <p:cSld>
     <p:spTree>
       <p:nvGrpSpPr>
@@ -14240,14 +13594,7 @@
         <p:cNvGrpSpPr/>
         <p:nvPr/>
       </p:nvGrpSpPr>
-      <p:grpSpPr>
-        <a:xfrm>
-          <a:off x="0" y="0"/>
-          <a:ext cx="0" cy="0"/>
-          <a:chOff x="0" y="0"/>
-          <a:chExt cx="0" cy="0"/>
-        </a:xfrm>
-      </p:grpSpPr>
+      <p:grpSpPr/>
       <p:sp>
         <p:nvSpPr>
           <p:cNvPr id="2" name="Rectangle 1"/>
@@ -14288,7 +13635,6 @@
           <a:lstStyle/>
           <a:p>
             <a:pPr algn="ctr"/>
-            <a:endParaRPr/>
           </a:p>
         </p:txBody>
       </p:sp>
@@ -14332,7 +13678,6 @@
           <a:lstStyle/>
           <a:p>
             <a:pPr algn="ctr"/>
-            <a:endParaRPr/>
           </a:p>
         </p:txBody>
       </p:sp>
@@ -14483,7 +13828,6 @@
           <a:lstStyle/>
           <a:p>
             <a:pPr algn="ctr"/>
-            <a:endParaRPr/>
           </a:p>
         </p:txBody>
       </p:sp>
@@ -14523,7 +13867,7 @@
           </a:fontRef>
         </p:style>
         <p:txBody>
-          <a:bodyPr wrap="none" rtlCol="0" anchor="ctr"/>
+          <a:bodyPr rtlCol="0" anchor="ctr" wrap="none"/>
           <a:lstStyle/>
           <a:p>
             <a:pPr algn="ctr"/>
@@ -14896,7 +14240,6 @@
           <a:lstStyle/>
           <a:p>
             <a:pPr algn="ctr"/>
-            <a:endParaRPr/>
           </a:p>
         </p:txBody>
       </p:sp>
@@ -14936,7 +14279,7 @@
           </a:fontRef>
         </p:style>
         <p:txBody>
-          <a:bodyPr wrap="none" rtlCol="0" anchor="ctr"/>
+          <a:bodyPr rtlCol="0" anchor="ctr" wrap="none"/>
           <a:lstStyle/>
           <a:p>
             <a:pPr algn="ctr"/>
@@ -15309,7 +14652,6 @@
           <a:lstStyle/>
           <a:p>
             <a:pPr algn="ctr"/>
-            <a:endParaRPr/>
           </a:p>
         </p:txBody>
       </p:sp>
@@ -15349,7 +14691,7 @@
           </a:fontRef>
         </p:style>
         <p:txBody>
-          <a:bodyPr wrap="none" rtlCol="0" anchor="ctr"/>
+          <a:bodyPr rtlCol="0" anchor="ctr" wrap="none"/>
           <a:lstStyle/>
           <a:p>
             <a:pPr algn="ctr"/>
@@ -15689,7 +15031,7 @@
 </file>
 
 <file path=ppt/slides/slide23.xml><?xml version="1.0" encoding="utf-8"?>
-<p:sld xmlns:a="http://schemas.openxmlformats.org/drawingml/2006/main" xmlns:r="http://schemas.openxmlformats.org/officeDocument/2006/relationships" xmlns:p="http://schemas.openxmlformats.org/presentationml/2006/main">
+<p:sld xmlns:a="http://schemas.openxmlformats.org/drawingml/2006/main" xmlns:p="http://schemas.openxmlformats.org/presentationml/2006/main" xmlns:r="http://schemas.openxmlformats.org/officeDocument/2006/relationships">
   <p:cSld>
     <p:spTree>
       <p:nvGrpSpPr>
@@ -15697,14 +15039,7 @@
         <p:cNvGrpSpPr/>
         <p:nvPr/>
       </p:nvGrpSpPr>
-      <p:grpSpPr>
-        <a:xfrm>
-          <a:off x="0" y="0"/>
-          <a:ext cx="0" cy="0"/>
-          <a:chOff x="0" y="0"/>
-          <a:chExt cx="0" cy="0"/>
-        </a:xfrm>
-      </p:grpSpPr>
+      <p:grpSpPr/>
       <p:sp>
         <p:nvSpPr>
           <p:cNvPr id="2" name="Rectangle 1"/>
@@ -15745,7 +15080,6 @@
           <a:lstStyle/>
           <a:p>
             <a:pPr algn="ctr"/>
-            <a:endParaRPr/>
           </a:p>
         </p:txBody>
       </p:sp>
@@ -15789,7 +15123,6 @@
           <a:lstStyle/>
           <a:p>
             <a:pPr algn="ctr"/>
-            <a:endParaRPr/>
           </a:p>
         </p:txBody>
       </p:sp>
@@ -15905,7 +15238,6 @@
           <a:lstStyle/>
           <a:p>
             <a:pPr algn="ctr"/>
-            <a:endParaRPr/>
           </a:p>
         </p:txBody>
       </p:sp>
@@ -16021,7 +15353,6 @@
           <a:lstStyle/>
           <a:p>
             <a:pPr algn="ctr"/>
-            <a:endParaRPr/>
           </a:p>
         </p:txBody>
       </p:sp>
@@ -16137,7 +15468,6 @@
           <a:lstStyle/>
           <a:p>
             <a:pPr algn="ctr"/>
-            <a:endParaRPr/>
           </a:p>
         </p:txBody>
       </p:sp>
@@ -16253,7 +15583,6 @@
           <a:lstStyle/>
           <a:p>
             <a:pPr algn="ctr"/>
-            <a:endParaRPr/>
           </a:p>
         </p:txBody>
       </p:sp>
@@ -16369,7 +15698,6 @@
           <a:lstStyle/>
           <a:p>
             <a:pPr algn="ctr"/>
-            <a:endParaRPr/>
           </a:p>
         </p:txBody>
       </p:sp>
@@ -16485,7 +15813,6 @@
           <a:lstStyle/>
           <a:p>
             <a:pPr algn="ctr"/>
-            <a:endParaRPr/>
           </a:p>
         </p:txBody>
       </p:sp>
@@ -16568,7 +15895,7 @@
 </file>
 
 <file path=ppt/slides/slide24.xml><?xml version="1.0" encoding="utf-8"?>
-<p:sld xmlns:a="http://schemas.openxmlformats.org/drawingml/2006/main" xmlns:r="http://schemas.openxmlformats.org/officeDocument/2006/relationships" xmlns:p="http://schemas.openxmlformats.org/presentationml/2006/main">
+<p:sld xmlns:a="http://schemas.openxmlformats.org/drawingml/2006/main" xmlns:p="http://schemas.openxmlformats.org/presentationml/2006/main" xmlns:r="http://schemas.openxmlformats.org/officeDocument/2006/relationships">
   <p:cSld>
     <p:spTree>
       <p:nvGrpSpPr>
@@ -16576,14 +15903,7 @@
         <p:cNvGrpSpPr/>
         <p:nvPr/>
       </p:nvGrpSpPr>
-      <p:grpSpPr>
-        <a:xfrm>
-          <a:off x="0" y="0"/>
-          <a:ext cx="0" cy="0"/>
-          <a:chOff x="0" y="0"/>
-          <a:chExt cx="0" cy="0"/>
-        </a:xfrm>
-      </p:grpSpPr>
+      <p:grpSpPr/>
       <p:sp>
         <p:nvSpPr>
           <p:cNvPr id="2" name="Rectangle 1"/>
@@ -16624,7 +15944,6 @@
           <a:lstStyle/>
           <a:p>
             <a:pPr algn="ctr"/>
-            <a:endParaRPr/>
           </a:p>
         </p:txBody>
       </p:sp>
@@ -16703,7 +16022,6 @@
           <a:lstStyle/>
           <a:p>
             <a:pPr algn="ctr"/>
-            <a:endParaRPr/>
           </a:p>
         </p:txBody>
       </p:sp>
@@ -16819,7 +16137,6 @@
           <a:lstStyle/>
           <a:p>
             <a:pPr algn="ctr"/>
-            <a:endParaRPr/>
           </a:p>
         </p:txBody>
       </p:sp>
@@ -16900,7 +16217,6 @@
           <a:lstStyle/>
           <a:p>
             <a:pPr algn="ctr"/>
-            <a:endParaRPr/>
           </a:p>
         </p:txBody>
       </p:sp>
@@ -16981,7 +16297,6 @@
           <a:lstStyle/>
           <a:p>
             <a:pPr algn="ctr"/>
-            <a:endParaRPr/>
           </a:p>
         </p:txBody>
       </p:sp>
@@ -17062,7 +16377,6 @@
           <a:lstStyle/>
           <a:p>
             <a:pPr algn="ctr"/>
-            <a:endParaRPr/>
           </a:p>
         </p:txBody>
       </p:sp>
@@ -17145,7 +16459,7 @@
 </file>
 
 <file path=ppt/slides/slide3.xml><?xml version="1.0" encoding="utf-8"?>
-<p:sld xmlns:a="http://schemas.openxmlformats.org/drawingml/2006/main" xmlns:r="http://schemas.openxmlformats.org/officeDocument/2006/relationships" xmlns:p="http://schemas.openxmlformats.org/presentationml/2006/main">
+<p:sld xmlns:a="http://schemas.openxmlformats.org/drawingml/2006/main" xmlns:p="http://schemas.openxmlformats.org/presentationml/2006/main" xmlns:r="http://schemas.openxmlformats.org/officeDocument/2006/relationships">
   <p:cSld>
     <p:spTree>
       <p:nvGrpSpPr>
@@ -17153,14 +16467,7 @@
         <p:cNvGrpSpPr/>
         <p:nvPr/>
       </p:nvGrpSpPr>
-      <p:grpSpPr>
-        <a:xfrm>
-          <a:off x="0" y="0"/>
-          <a:ext cx="0" cy="0"/>
-          <a:chOff x="0" y="0"/>
-          <a:chExt cx="0" cy="0"/>
-        </a:xfrm>
-      </p:grpSpPr>
+      <p:grpSpPr/>
       <p:sp>
         <p:nvSpPr>
           <p:cNvPr id="2" name="Rectangle 1"/>
@@ -17201,7 +16508,6 @@
           <a:lstStyle/>
           <a:p>
             <a:pPr algn="ctr"/>
-            <a:endParaRPr/>
           </a:p>
         </p:txBody>
       </p:sp>
@@ -17245,7 +16551,6 @@
           <a:lstStyle/>
           <a:p>
             <a:pPr algn="ctr"/>
-            <a:endParaRPr/>
           </a:p>
         </p:txBody>
       </p:sp>
@@ -17396,7 +16701,6 @@
           <a:lstStyle/>
           <a:p>
             <a:pPr algn="ctr"/>
-            <a:endParaRPr/>
           </a:p>
         </p:txBody>
       </p:sp>
@@ -17436,7 +16740,7 @@
           </a:fontRef>
         </p:style>
         <p:txBody>
-          <a:bodyPr wrap="none" rtlCol="0" anchor="ctr"/>
+          <a:bodyPr rtlCol="0" anchor="ctr" wrap="none"/>
           <a:lstStyle/>
           <a:p>
             <a:pPr algn="ctr"/>
@@ -17844,7 +17148,6 @@
           <a:lstStyle/>
           <a:p>
             <a:pPr algn="ctr"/>
-            <a:endParaRPr/>
           </a:p>
         </p:txBody>
       </p:sp>
@@ -17884,7 +17187,7 @@
           </a:fontRef>
         </p:style>
         <p:txBody>
-          <a:bodyPr wrap="none" rtlCol="0" anchor="ctr"/>
+          <a:bodyPr rtlCol="0" anchor="ctr" wrap="none"/>
           <a:lstStyle/>
           <a:p>
             <a:pPr algn="ctr"/>
@@ -18259,7 +17562,7 @@
 </file>
 
 <file path=ppt/slides/slide4.xml><?xml version="1.0" encoding="utf-8"?>
-<p:sld xmlns:a="http://schemas.openxmlformats.org/drawingml/2006/main" xmlns:r="http://schemas.openxmlformats.org/officeDocument/2006/relationships" xmlns:p="http://schemas.openxmlformats.org/presentationml/2006/main">
+<p:sld xmlns:a="http://schemas.openxmlformats.org/drawingml/2006/main" xmlns:p="http://schemas.openxmlformats.org/presentationml/2006/main" xmlns:r="http://schemas.openxmlformats.org/officeDocument/2006/relationships">
   <p:cSld>
     <p:spTree>
       <p:nvGrpSpPr>
@@ -18267,14 +17570,7 @@
         <p:cNvGrpSpPr/>
         <p:nvPr/>
       </p:nvGrpSpPr>
-      <p:grpSpPr>
-        <a:xfrm>
-          <a:off x="0" y="0"/>
-          <a:ext cx="0" cy="0"/>
-          <a:chOff x="0" y="0"/>
-          <a:chExt cx="0" cy="0"/>
-        </a:xfrm>
-      </p:grpSpPr>
+      <p:grpSpPr/>
       <p:sp>
         <p:nvSpPr>
           <p:cNvPr id="2" name="Rectangle 1"/>
@@ -18315,7 +17611,6 @@
           <a:lstStyle/>
           <a:p>
             <a:pPr algn="ctr"/>
-            <a:endParaRPr/>
           </a:p>
         </p:txBody>
       </p:sp>
@@ -18359,7 +17654,6 @@
           <a:lstStyle/>
           <a:p>
             <a:pPr algn="ctr"/>
-            <a:endParaRPr/>
           </a:p>
         </p:txBody>
       </p:sp>
@@ -18475,7 +17769,6 @@
           <a:lstStyle/>
           <a:p>
             <a:pPr algn="ctr"/>
-            <a:endParaRPr/>
           </a:p>
         </p:txBody>
       </p:sp>
@@ -18557,7 +17850,6 @@
           <a:lstStyle/>
           <a:p>
             <a:pPr algn="ctr"/>
-            <a:endParaRPr/>
           </a:p>
         </p:txBody>
       </p:sp>
@@ -18639,7 +17931,6 @@
           <a:lstStyle/>
           <a:p>
             <a:pPr algn="ctr"/>
-            <a:endParaRPr/>
           </a:p>
         </p:txBody>
       </p:sp>
@@ -18721,7 +18012,6 @@
           <a:lstStyle/>
           <a:p>
             <a:pPr algn="ctr"/>
-            <a:endParaRPr/>
           </a:p>
         </p:txBody>
       </p:sp>
@@ -19190,7 +18480,7 @@
 </file>
 
 <file path=ppt/slides/slide5.xml><?xml version="1.0" encoding="utf-8"?>
-<p:sld xmlns:a="http://schemas.openxmlformats.org/drawingml/2006/main" xmlns:r="http://schemas.openxmlformats.org/officeDocument/2006/relationships" xmlns:p="http://schemas.openxmlformats.org/presentationml/2006/main">
+<p:sld xmlns:a="http://schemas.openxmlformats.org/drawingml/2006/main" xmlns:p="http://schemas.openxmlformats.org/presentationml/2006/main" xmlns:r="http://schemas.openxmlformats.org/officeDocument/2006/relationships">
   <p:cSld>
     <p:spTree>
       <p:nvGrpSpPr>
@@ -19198,14 +18488,7 @@
         <p:cNvGrpSpPr/>
         <p:nvPr/>
       </p:nvGrpSpPr>
-      <p:grpSpPr>
-        <a:xfrm>
-          <a:off x="0" y="0"/>
-          <a:ext cx="0" cy="0"/>
-          <a:chOff x="0" y="0"/>
-          <a:chExt cx="0" cy="0"/>
-        </a:xfrm>
-      </p:grpSpPr>
+      <p:grpSpPr/>
       <p:sp>
         <p:nvSpPr>
           <p:cNvPr id="2" name="Rectangle 1"/>
@@ -19246,7 +18529,6 @@
           <a:lstStyle/>
           <a:p>
             <a:pPr algn="ctr"/>
-            <a:endParaRPr/>
           </a:p>
         </p:txBody>
       </p:sp>
@@ -19290,7 +18572,6 @@
           <a:lstStyle/>
           <a:p>
             <a:pPr algn="ctr"/>
-            <a:endParaRPr/>
           </a:p>
         </p:txBody>
       </p:sp>
@@ -19388,7 +18669,7 @@
           <a:p>
             <a:pPr algn="l"/>
             <a:r>
-              <a:rPr sz="1600" b="0" i="0" dirty="0">
+              <a:rPr sz="1600" b="0" i="0">
                 <a:solidFill>
                   <a:srgbClr val="B0BCD4"/>
                 </a:solidFill>
@@ -19441,7 +18722,6 @@
           <a:lstStyle/>
           <a:p>
             <a:pPr algn="ctr"/>
-            <a:endParaRPr/>
           </a:p>
         </p:txBody>
       </p:sp>
@@ -19557,7 +18837,6 @@
           <a:lstStyle/>
           <a:p>
             <a:pPr algn="ctr"/>
-            <a:endParaRPr/>
           </a:p>
         </p:txBody>
       </p:sp>
@@ -19673,7 +18952,6 @@
           <a:lstStyle/>
           <a:p>
             <a:pPr algn="ctr"/>
-            <a:endParaRPr/>
           </a:p>
         </p:txBody>
       </p:sp>
@@ -19789,7 +19067,6 @@
           <a:lstStyle/>
           <a:p>
             <a:pPr algn="ctr"/>
-            <a:endParaRPr/>
           </a:p>
         </p:txBody>
       </p:sp>
@@ -19905,7 +19182,6 @@
           <a:lstStyle/>
           <a:p>
             <a:pPr algn="ctr"/>
-            <a:endParaRPr/>
           </a:p>
         </p:txBody>
       </p:sp>
@@ -20021,7 +19297,6 @@
           <a:lstStyle/>
           <a:p>
             <a:pPr algn="ctr"/>
-            <a:endParaRPr/>
           </a:p>
         </p:txBody>
       </p:sp>
@@ -20104,7 +19379,7 @@
 </file>
 
 <file path=ppt/slides/slide6.xml><?xml version="1.0" encoding="utf-8"?>
-<p:sld xmlns:a="http://schemas.openxmlformats.org/drawingml/2006/main" xmlns:r="http://schemas.openxmlformats.org/officeDocument/2006/relationships" xmlns:p="http://schemas.openxmlformats.org/presentationml/2006/main">
+<p:sld xmlns:a="http://schemas.openxmlformats.org/drawingml/2006/main" xmlns:p="http://schemas.openxmlformats.org/presentationml/2006/main" xmlns:r="http://schemas.openxmlformats.org/officeDocument/2006/relationships">
   <p:cSld>
     <p:spTree>
       <p:nvGrpSpPr>
@@ -20112,14 +19387,7 @@
         <p:cNvGrpSpPr/>
         <p:nvPr/>
       </p:nvGrpSpPr>
-      <p:grpSpPr>
-        <a:xfrm>
-          <a:off x="0" y="0"/>
-          <a:ext cx="0" cy="0"/>
-          <a:chOff x="0" y="0"/>
-          <a:chExt cx="0" cy="0"/>
-        </a:xfrm>
-      </p:grpSpPr>
+      <p:grpSpPr/>
       <p:sp>
         <p:nvSpPr>
           <p:cNvPr id="2" name="Rectangle 1"/>
@@ -20160,7 +19428,6 @@
           <a:lstStyle/>
           <a:p>
             <a:pPr algn="ctr"/>
-            <a:endParaRPr/>
           </a:p>
         </p:txBody>
       </p:sp>
@@ -20204,7 +19471,6 @@
           <a:lstStyle/>
           <a:p>
             <a:pPr algn="ctr"/>
-            <a:endParaRPr/>
           </a:p>
         </p:txBody>
       </p:sp>
@@ -20302,7 +19568,7 @@
           <a:p>
             <a:pPr algn="l"/>
             <a:r>
-              <a:rPr sz="1500" b="0" i="0" dirty="0">
+              <a:rPr sz="1500" b="0" i="0">
                 <a:solidFill>
                   <a:srgbClr val="B0BCD4"/>
                 </a:solidFill>
@@ -20355,7 +19621,6 @@
           <a:lstStyle/>
           <a:p>
             <a:pPr algn="ctr"/>
-            <a:endParaRPr/>
           </a:p>
         </p:txBody>
       </p:sp>
@@ -20450,7 +19715,6 @@
           <a:lstStyle/>
           <a:p>
             <a:pPr algn="ctr"/>
-            <a:endParaRPr/>
           </a:p>
         </p:txBody>
       </p:sp>
@@ -20566,7 +19830,6 @@
           <a:lstStyle/>
           <a:p>
             <a:pPr algn="ctr"/>
-            <a:endParaRPr/>
           </a:p>
         </p:txBody>
       </p:sp>
@@ -20682,7 +19945,6 @@
           <a:lstStyle/>
           <a:p>
             <a:pPr algn="ctr"/>
-            <a:endParaRPr/>
           </a:p>
         </p:txBody>
       </p:sp>
@@ -20798,7 +20060,6 @@
           <a:lstStyle/>
           <a:p>
             <a:pPr algn="ctr"/>
-            <a:endParaRPr/>
           </a:p>
         </p:txBody>
       </p:sp>
@@ -20881,7 +20142,7 @@
 </file>
 
 <file path=ppt/slides/slide7.xml><?xml version="1.0" encoding="utf-8"?>
-<p:sld xmlns:a="http://schemas.openxmlformats.org/drawingml/2006/main" xmlns:r="http://schemas.openxmlformats.org/officeDocument/2006/relationships" xmlns:p="http://schemas.openxmlformats.org/presentationml/2006/main">
+<p:sld xmlns:a="http://schemas.openxmlformats.org/drawingml/2006/main" xmlns:p="http://schemas.openxmlformats.org/presentationml/2006/main" xmlns:r="http://schemas.openxmlformats.org/officeDocument/2006/relationships">
   <p:cSld>
     <p:spTree>
       <p:nvGrpSpPr>
@@ -20889,14 +20150,7 @@
         <p:cNvGrpSpPr/>
         <p:nvPr/>
       </p:nvGrpSpPr>
-      <p:grpSpPr>
-        <a:xfrm>
-          <a:off x="0" y="0"/>
-          <a:ext cx="0" cy="0"/>
-          <a:chOff x="0" y="0"/>
-          <a:chExt cx="0" cy="0"/>
-        </a:xfrm>
-      </p:grpSpPr>
+      <p:grpSpPr/>
       <p:sp>
         <p:nvSpPr>
           <p:cNvPr id="2" name="Rectangle 1"/>
@@ -20937,7 +20191,6 @@
           <a:lstStyle/>
           <a:p>
             <a:pPr algn="ctr"/>
-            <a:endParaRPr/>
           </a:p>
         </p:txBody>
       </p:sp>
@@ -20981,7 +20234,6 @@
           <a:lstStyle/>
           <a:p>
             <a:pPr algn="ctr"/>
-            <a:endParaRPr/>
           </a:p>
         </p:txBody>
       </p:sp>
@@ -21132,7 +20384,6 @@
           <a:lstStyle/>
           <a:p>
             <a:pPr algn="ctr"/>
-            <a:endParaRPr/>
           </a:p>
         </p:txBody>
       </p:sp>
@@ -21236,7 +20487,6 @@
           <a:lstStyle/>
           <a:p>
             <a:pPr algn="ctr"/>
-            <a:endParaRPr/>
           </a:p>
         </p:txBody>
       </p:sp>
@@ -21352,7 +20602,6 @@
           <a:lstStyle/>
           <a:p>
             <a:pPr algn="ctr"/>
-            <a:endParaRPr/>
           </a:p>
         </p:txBody>
       </p:sp>
@@ -21468,7 +20717,6 @@
           <a:lstStyle/>
           <a:p>
             <a:pPr algn="ctr"/>
-            <a:endParaRPr/>
           </a:p>
         </p:txBody>
       </p:sp>
@@ -21584,7 +20832,6 @@
           <a:lstStyle/>
           <a:p>
             <a:pPr algn="ctr"/>
-            <a:endParaRPr/>
           </a:p>
         </p:txBody>
       </p:sp>
@@ -21667,7 +20914,7 @@
 </file>
 
 <file path=ppt/slides/slide8.xml><?xml version="1.0" encoding="utf-8"?>
-<p:sld xmlns:a="http://schemas.openxmlformats.org/drawingml/2006/main" xmlns:r="http://schemas.openxmlformats.org/officeDocument/2006/relationships" xmlns:p="http://schemas.openxmlformats.org/presentationml/2006/main">
+<p:sld xmlns:a="http://schemas.openxmlformats.org/drawingml/2006/main" xmlns:p="http://schemas.openxmlformats.org/presentationml/2006/main" xmlns:r="http://schemas.openxmlformats.org/officeDocument/2006/relationships">
   <p:cSld>
     <p:spTree>
       <p:nvGrpSpPr>
@@ -21675,14 +20922,7 @@
         <p:cNvGrpSpPr/>
         <p:nvPr/>
       </p:nvGrpSpPr>
-      <p:grpSpPr>
-        <a:xfrm>
-          <a:off x="0" y="0"/>
-          <a:ext cx="0" cy="0"/>
-          <a:chOff x="0" y="0"/>
-          <a:chExt cx="0" cy="0"/>
-        </a:xfrm>
-      </p:grpSpPr>
+      <p:grpSpPr/>
       <p:sp>
         <p:nvSpPr>
           <p:cNvPr id="2" name="Rectangle 1"/>
@@ -21723,7 +20963,6 @@
           <a:lstStyle/>
           <a:p>
             <a:pPr algn="ctr"/>
-            <a:endParaRPr/>
           </a:p>
         </p:txBody>
       </p:sp>
@@ -21767,7 +21006,6 @@
           <a:lstStyle/>
           <a:p>
             <a:pPr algn="ctr"/>
-            <a:endParaRPr/>
           </a:p>
         </p:txBody>
       </p:sp>
@@ -21918,7 +21156,6 @@
           <a:lstStyle/>
           <a:p>
             <a:pPr algn="ctr"/>
-            <a:endParaRPr/>
           </a:p>
         </p:txBody>
       </p:sp>
@@ -22014,7 +21251,6 @@
           <a:lstStyle/>
           <a:p>
             <a:pPr algn="ctr"/>
-            <a:endParaRPr/>
           </a:p>
         </p:txBody>
       </p:sp>
@@ -22132,7 +21368,6 @@
           <a:lstStyle/>
           <a:p>
             <a:pPr algn="ctr"/>
-            <a:endParaRPr/>
           </a:p>
         </p:txBody>
       </p:sp>
@@ -22249,7 +21484,6 @@
           <a:lstStyle/>
           <a:p>
             <a:pPr algn="ctr"/>
-            <a:endParaRPr/>
           </a:p>
         </p:txBody>
       </p:sp>
@@ -22333,7 +21567,7 @@
 </file>
 
 <file path=ppt/slides/slide9.xml><?xml version="1.0" encoding="utf-8"?>
-<p:sld xmlns:a="http://schemas.openxmlformats.org/drawingml/2006/main" xmlns:r="http://schemas.openxmlformats.org/officeDocument/2006/relationships" xmlns:p="http://schemas.openxmlformats.org/presentationml/2006/main">
+<p:sld xmlns:a="http://schemas.openxmlformats.org/drawingml/2006/main" xmlns:p="http://schemas.openxmlformats.org/presentationml/2006/main" xmlns:r="http://schemas.openxmlformats.org/officeDocument/2006/relationships">
   <p:cSld>
     <p:spTree>
       <p:nvGrpSpPr>
@@ -22341,14 +21575,7 @@
         <p:cNvGrpSpPr/>
         <p:nvPr/>
       </p:nvGrpSpPr>
-      <p:grpSpPr>
-        <a:xfrm>
-          <a:off x="0" y="0"/>
-          <a:ext cx="0" cy="0"/>
-          <a:chOff x="0" y="0"/>
-          <a:chExt cx="0" cy="0"/>
-        </a:xfrm>
-      </p:grpSpPr>
+      <p:grpSpPr/>
       <p:sp>
         <p:nvSpPr>
           <p:cNvPr id="2" name="Rectangle 1"/>
@@ -22389,7 +21616,6 @@
           <a:lstStyle/>
           <a:p>
             <a:pPr algn="ctr"/>
-            <a:endParaRPr/>
           </a:p>
         </p:txBody>
       </p:sp>
@@ -22433,7 +21659,6 @@
           <a:lstStyle/>
           <a:p>
             <a:pPr algn="ctr"/>
-            <a:endParaRPr/>
           </a:p>
         </p:txBody>
       </p:sp>
@@ -22584,7 +21809,6 @@
           <a:lstStyle/>
           <a:p>
             <a:pPr algn="ctr"/>
-            <a:endParaRPr/>
           </a:p>
         </p:txBody>
       </p:sp>
@@ -22684,7 +21908,6 @@
           <a:lstStyle/>
           <a:p>
             <a:pPr algn="ctr"/>
-            <a:endParaRPr/>
           </a:p>
         </p:txBody>
       </p:sp>

</xml_diff>